<commit_message>
docs: add external citations to scale slide and SLIDES.md
- Slide 3 (Scale of Impact) rebuilt with two-row card layout:
  INDUSTRY row: EMA Research $14,056/min, Trantornic 31%, Rootly 40% MTTR
  INFRABRAIN row: our 30% override, 1.3 min MTTR, 0 retained corrections
  Source footer: EMA Research 2024 · Trantornic 2024-25 · Rootly 2025 · infrabrain-eval
- SLIDES.md: inline citation markers [¹–⁴] + full References section with URLs
  for all external stats and academic papers

Co-Authored-By: Claude Sonnet 4.6 <noreply@anthropic.com>
</commit_message>
<xml_diff>
--- a/InfraBrain_Presentation.pptx
+++ b/InfraBrain_Presentation.pptx
@@ -3446,19 +3446,56 @@
       </p:sp>
       <p:sp>
         <p:nvSpPr>
-          <p:cNvPr id="5" name="Shape 3"/>
-          <p:cNvSpPr/>
-          <p:nvPr/>
-        </p:nvSpPr>
-        <p:spPr>
-          <a:xfrm>
-            <a:off x="411480" y="1371600"/>
-            <a:ext cx="2468880" cy="1417320"/>
-          </a:xfrm>
-          <a:prstGeom prst="rect">
-            <a:avLst>
-              <a:gd name="adj" fmla="val 5161"/>
-            </a:avLst>
+          <p:cNvPr id="5" name="Text 3"/>
+          <p:cNvSpPr/>
+          <p:nvPr/>
+        </p:nvSpPr>
+        <p:spPr>
+          <a:xfrm>
+            <a:off x="411480" y="1298448"/>
+            <a:ext cx="1097280" cy="201168"/>
+          </a:xfrm>
+          <a:prstGeom prst="rect">
+            <a:avLst/>
+          </a:prstGeom>
+          <a:noFill/>
+          <a:ln/>
+        </p:spPr>
+        <p:txBody>
+          <a:bodyPr wrap="square" lIns="0" tIns="0" rIns="0" bIns="0" rtlCol="0" anchor="ctr"/>
+          <a:lstStyle/>
+          <a:p>
+            <a:pPr indent="0" marL="0">
+              <a:buNone/>
+            </a:pPr>
+            <a:r>
+              <a:rPr lang="en-US" sz="800" b="1" spc="300" kern="0" dirty="0">
+                <a:solidFill>
+                  <a:srgbClr val="94A3B8"/>
+                </a:solidFill>
+                <a:latin typeface="Calibri" pitchFamily="34" charset="0"/>
+                <a:ea typeface="Calibri" pitchFamily="34" charset="-122"/>
+                <a:cs typeface="Calibri" pitchFamily="34" charset="-120"/>
+              </a:rPr>
+              <a:t>INDUSTRY</a:t>
+            </a:r>
+            <a:endParaRPr lang="en-US" sz="800" dirty="0"/>
+          </a:p>
+        </p:txBody>
+      </p:sp>
+      <p:sp>
+        <p:nvSpPr>
+          <p:cNvPr id="6" name="Shape 4"/>
+          <p:cNvSpPr/>
+          <p:nvPr/>
+        </p:nvSpPr>
+        <p:spPr>
+          <a:xfrm>
+            <a:off x="411480" y="1508760"/>
+            <a:ext cx="2468880" cy="1261872"/>
+          </a:xfrm>
+          <a:prstGeom prst="rect">
+            <a:avLst/>
           </a:prstGeom>
           <a:solidFill>
             <a:srgbClr val="131D30"/>
@@ -3468,14 +3505,34 @@
       </p:sp>
       <p:sp>
         <p:nvSpPr>
-          <p:cNvPr id="6" name="Text 4"/>
-          <p:cNvSpPr/>
-          <p:nvPr/>
-        </p:nvSpPr>
-        <p:spPr>
-          <a:xfrm>
-            <a:off x="576072" y="1499616"/>
-            <a:ext cx="2139696" cy="640080"/>
+          <p:cNvPr id="7" name="Shape 5"/>
+          <p:cNvSpPr/>
+          <p:nvPr/>
+        </p:nvSpPr>
+        <p:spPr>
+          <a:xfrm>
+            <a:off x="411480" y="1508760"/>
+            <a:ext cx="2468880" cy="45720"/>
+          </a:xfrm>
+          <a:prstGeom prst="rect">
+            <a:avLst/>
+          </a:prstGeom>
+          <a:solidFill>
+            <a:srgbClr val="F87171"/>
+          </a:solidFill>
+          <a:ln/>
+        </p:spPr>
+      </p:sp>
+      <p:sp>
+        <p:nvSpPr>
+          <p:cNvPr id="8" name="Text 6"/>
+          <p:cNvSpPr/>
+          <p:nvPr/>
+        </p:nvSpPr>
+        <p:spPr>
+          <a:xfrm>
+            <a:off x="521208" y="1600200"/>
+            <a:ext cx="2249424" cy="475488"/>
           </a:xfrm>
           <a:prstGeom prst="rect">
             <a:avLst/>
@@ -3491,7 +3548,7 @@
               <a:buNone/>
             </a:pPr>
             <a:r>
-              <a:rPr lang="en-US" sz="3600" b="1" dirty="0">
+              <a:rPr lang="en-US" sz="3000" b="1" dirty="0">
                 <a:solidFill>
                   <a:srgbClr val="F87171"/>
                 </a:solidFill>
@@ -3499,22 +3556,22 @@
                 <a:ea typeface="Calibri" pitchFamily="34" charset="-122"/>
                 <a:cs typeface="Calibri" pitchFamily="34" charset="-120"/>
               </a:rPr>
-              <a:t>30%</a:t>
-            </a:r>
-            <a:endParaRPr lang="en-US" sz="3600" dirty="0"/>
-          </a:p>
-        </p:txBody>
-      </p:sp>
-      <p:sp>
-        <p:nvSpPr>
-          <p:cNvPr id="7" name="Text 5"/>
-          <p:cNvSpPr/>
-          <p:nvPr/>
-        </p:nvSpPr>
-        <p:spPr>
-          <a:xfrm>
-            <a:off x="521208" y="2084832"/>
-            <a:ext cx="2249424" cy="256032"/>
+              <a:t>$14,056</a:t>
+            </a:r>
+            <a:endParaRPr lang="en-US" sz="3000" dirty="0"/>
+          </a:p>
+        </p:txBody>
+      </p:sp>
+      <p:sp>
+        <p:nvSpPr>
+          <p:cNvPr id="9" name="Text 7"/>
+          <p:cNvSpPr/>
+          <p:nvPr/>
+        </p:nvSpPr>
+        <p:spPr>
+          <a:xfrm>
+            <a:off x="521208" y="2075688"/>
+            <a:ext cx="2249424" cy="219456"/>
           </a:xfrm>
           <a:prstGeom prst="rect">
             <a:avLst/>
@@ -3530,7 +3587,7 @@
               <a:buNone/>
             </a:pPr>
             <a:r>
-              <a:rPr lang="en-US" sz="1200" b="1" dirty="0">
+              <a:rPr lang="en-US" sz="1100" b="1" dirty="0">
                 <a:solidFill>
                   <a:srgbClr val="FFFFFF"/>
                 </a:solidFill>
@@ -3538,22 +3595,22 @@
                 <a:ea typeface="Calibri" pitchFamily="34" charset="-122"/>
                 <a:cs typeface="Calibri" pitchFamily="34" charset="-120"/>
               </a:rPr>
-              <a:t>Faults Misdiagnosed</a:t>
-            </a:r>
-            <a:endParaRPr lang="en-US" sz="1200" dirty="0"/>
-          </a:p>
-        </p:txBody>
-      </p:sp>
-      <p:sp>
-        <p:nvSpPr>
-          <p:cNvPr id="8" name="Text 6"/>
-          <p:cNvSpPr/>
-          <p:nvPr/>
-        </p:nvSpPr>
-        <p:spPr>
-          <a:xfrm>
-            <a:off x="521208" y="2322576"/>
-            <a:ext cx="2249424" cy="256032"/>
+              <a:t>Per Minute</a:t>
+            </a:r>
+            <a:endParaRPr lang="en-US" sz="1100" dirty="0"/>
+          </a:p>
+        </p:txBody>
+      </p:sp>
+      <p:sp>
+        <p:nvSpPr>
+          <p:cNvPr id="10" name="Text 8"/>
+          <p:cNvSpPr/>
+          <p:nvPr/>
+        </p:nvSpPr>
+        <p:spPr>
+          <a:xfrm>
+            <a:off x="521208" y="2286000"/>
+            <a:ext cx="2249424" cy="274320"/>
           </a:xfrm>
           <a:prstGeom prst="rect">
             <a:avLst/>
@@ -3569,7 +3626,7 @@
               <a:buNone/>
             </a:pPr>
             <a:r>
-              <a:rPr lang="en-US" sz="1000" dirty="0">
+              <a:rPr lang="en-US" sz="900" dirty="0">
                 <a:solidFill>
                   <a:srgbClr val="94A3B8"/>
                 </a:solidFill>
@@ -3577,16 +3634,16 @@
                 <a:ea typeface="Calibri" pitchFamily="34" charset="-122"/>
                 <a:cs typeface="Calibri" pitchFamily="34" charset="-120"/>
               </a:rPr>
-              <a:t>at baseline with no</a:t>
-            </a:r>
-            <a:endParaRPr lang="en-US" sz="1000" dirty="0"/>
+              <a:t>avg cost of unplanned</a:t>
+            </a:r>
+            <a:endParaRPr lang="en-US" sz="900" dirty="0"/>
           </a:p>
           <a:p>
             <a:pPr algn="ctr" indent="0" marL="0">
               <a:buNone/>
             </a:pPr>
             <a:r>
-              <a:rPr lang="en-US" sz="1000" dirty="0">
+              <a:rPr lang="en-US" sz="900" dirty="0">
                 <a:solidFill>
                   <a:srgbClr val="94A3B8"/>
                 </a:solidFill>
@@ -3594,27 +3651,64 @@
                 <a:ea typeface="Calibri" pitchFamily="34" charset="-122"/>
                 <a:cs typeface="Calibri" pitchFamily="34" charset="-120"/>
               </a:rPr>
-              <a:t>KG context (real Gemini data)</a:t>
-            </a:r>
-            <a:endParaRPr lang="en-US" sz="1000" dirty="0"/>
-          </a:p>
-        </p:txBody>
-      </p:sp>
-      <p:sp>
-        <p:nvSpPr>
-          <p:cNvPr id="9" name="Shape 7"/>
-          <p:cNvSpPr/>
-          <p:nvPr/>
-        </p:nvSpPr>
-        <p:spPr>
-          <a:xfrm>
-            <a:off x="3337560" y="1371600"/>
-            <a:ext cx="2468880" cy="1417320"/>
-          </a:xfrm>
-          <a:prstGeom prst="rect">
-            <a:avLst>
-              <a:gd name="adj" fmla="val 5161"/>
-            </a:avLst>
+              <a:t>infrastructure downtime</a:t>
+            </a:r>
+            <a:endParaRPr lang="en-US" sz="900" dirty="0"/>
+          </a:p>
+        </p:txBody>
+      </p:sp>
+      <p:sp>
+        <p:nvSpPr>
+          <p:cNvPr id="11" name="Text 9"/>
+          <p:cNvSpPr/>
+          <p:nvPr/>
+        </p:nvSpPr>
+        <p:spPr>
+          <a:xfrm>
+            <a:off x="521208" y="2587752"/>
+            <a:ext cx="2249424" cy="146304"/>
+          </a:xfrm>
+          <a:prstGeom prst="rect">
+            <a:avLst/>
+          </a:prstGeom>
+          <a:noFill/>
+          <a:ln/>
+        </p:spPr>
+        <p:txBody>
+          <a:bodyPr wrap="square" lIns="0" tIns="0" rIns="0" bIns="0" rtlCol="0" anchor="ctr"/>
+          <a:lstStyle/>
+          <a:p>
+            <a:pPr algn="ctr" indent="0" marL="0">
+              <a:buNone/>
+            </a:pPr>
+            <a:r>
+              <a:rPr lang="en-US" sz="800" i="1" dirty="0">
+                <a:solidFill>
+                  <a:srgbClr val="F87171"/>
+                </a:solidFill>
+                <a:latin typeface="Calibri" pitchFamily="34" charset="0"/>
+                <a:ea typeface="Calibri" pitchFamily="34" charset="-122"/>
+                <a:cs typeface="Calibri" pitchFamily="34" charset="-120"/>
+              </a:rPr>
+              <a:t>EMA Research, 2024</a:t>
+            </a:r>
+            <a:endParaRPr lang="en-US" sz="800" dirty="0"/>
+          </a:p>
+        </p:txBody>
+      </p:sp>
+      <p:sp>
+        <p:nvSpPr>
+          <p:cNvPr id="12" name="Shape 10"/>
+          <p:cNvSpPr/>
+          <p:nvPr/>
+        </p:nvSpPr>
+        <p:spPr>
+          <a:xfrm>
+            <a:off x="3337560" y="1508760"/>
+            <a:ext cx="2468880" cy="1261872"/>
+          </a:xfrm>
+          <a:prstGeom prst="rect">
+            <a:avLst/>
           </a:prstGeom>
           <a:solidFill>
             <a:srgbClr val="131D30"/>
@@ -3624,14 +3718,34 @@
       </p:sp>
       <p:sp>
         <p:nvSpPr>
-          <p:cNvPr id="10" name="Text 8"/>
-          <p:cNvSpPr/>
-          <p:nvPr/>
-        </p:nvSpPr>
-        <p:spPr>
-          <a:xfrm>
-            <a:off x="3502152" y="1499616"/>
-            <a:ext cx="2139696" cy="640080"/>
+          <p:cNvPr id="13" name="Shape 11"/>
+          <p:cNvSpPr/>
+          <p:nvPr/>
+        </p:nvSpPr>
+        <p:spPr>
+          <a:xfrm>
+            <a:off x="3337560" y="1508760"/>
+            <a:ext cx="2468880" cy="45720"/>
+          </a:xfrm>
+          <a:prstGeom prst="rect">
+            <a:avLst/>
+          </a:prstGeom>
+          <a:solidFill>
+            <a:srgbClr val="FBBF24"/>
+          </a:solidFill>
+          <a:ln/>
+        </p:spPr>
+      </p:sp>
+      <p:sp>
+        <p:nvSpPr>
+          <p:cNvPr id="14" name="Text 12"/>
+          <p:cNvSpPr/>
+          <p:nvPr/>
+        </p:nvSpPr>
+        <p:spPr>
+          <a:xfrm>
+            <a:off x="3447288" y="1600200"/>
+            <a:ext cx="2249424" cy="475488"/>
           </a:xfrm>
           <a:prstGeom prst="rect">
             <a:avLst/>
@@ -3647,7 +3761,7 @@
               <a:buNone/>
             </a:pPr>
             <a:r>
-              <a:rPr lang="en-US" sz="3600" b="1" dirty="0">
+              <a:rPr lang="en-US" sz="3000" b="1" dirty="0">
                 <a:solidFill>
                   <a:srgbClr val="FBBF24"/>
                 </a:solidFill>
@@ -3655,22 +3769,22 @@
                 <a:ea typeface="Calibri" pitchFamily="34" charset="-122"/>
                 <a:cs typeface="Calibri" pitchFamily="34" charset="-120"/>
               </a:rPr>
-              <a:t>1.3 min</a:t>
-            </a:r>
-            <a:endParaRPr lang="en-US" sz="3600" dirty="0"/>
-          </a:p>
-        </p:txBody>
-      </p:sp>
-      <p:sp>
-        <p:nvSpPr>
-          <p:cNvPr id="11" name="Text 9"/>
-          <p:cNvSpPr/>
-          <p:nvPr/>
-        </p:nvSpPr>
-        <p:spPr>
-          <a:xfrm>
-            <a:off x="3447288" y="2084832"/>
-            <a:ext cx="2249424" cy="256032"/>
+              <a:t>31%</a:t>
+            </a:r>
+            <a:endParaRPr lang="en-US" sz="3000" dirty="0"/>
+          </a:p>
+        </p:txBody>
+      </p:sp>
+      <p:sp>
+        <p:nvSpPr>
+          <p:cNvPr id="15" name="Text 13"/>
+          <p:cNvSpPr/>
+          <p:nvPr/>
+        </p:nvSpPr>
+        <p:spPr>
+          <a:xfrm>
+            <a:off x="3447288" y="2075688"/>
+            <a:ext cx="2249424" cy="219456"/>
           </a:xfrm>
           <a:prstGeom prst="rect">
             <a:avLst/>
@@ -3686,7 +3800,7 @@
               <a:buNone/>
             </a:pPr>
             <a:r>
-              <a:rPr lang="en-US" sz="1200" b="1" dirty="0">
+              <a:rPr lang="en-US" sz="1100" b="1" dirty="0">
                 <a:solidFill>
                   <a:srgbClr val="FFFFFF"/>
                 </a:solidFill>
@@ -3694,22 +3808,22 @@
                 <a:ea typeface="Calibri" pitchFamily="34" charset="-122"/>
                 <a:cs typeface="Calibri" pitchFamily="34" charset="-120"/>
               </a:rPr>
-              <a:t>MTTR Wasted Per Fault</a:t>
-            </a:r>
-            <a:endParaRPr lang="en-US" sz="1200" dirty="0"/>
-          </a:p>
-        </p:txBody>
-      </p:sp>
-      <p:sp>
-        <p:nvSpPr>
-          <p:cNvPr id="12" name="Text 10"/>
-          <p:cNvSpPr/>
-          <p:nvPr/>
-        </p:nvSpPr>
-        <p:spPr>
-          <a:xfrm>
-            <a:off x="3447288" y="2322576"/>
-            <a:ext cx="2249424" cy="256032"/>
+              <a:t>Agent Failures</a:t>
+            </a:r>
+            <a:endParaRPr lang="en-US" sz="1100" dirty="0"/>
+          </a:p>
+        </p:txBody>
+      </p:sp>
+      <p:sp>
+        <p:nvSpPr>
+          <p:cNvPr id="16" name="Text 14"/>
+          <p:cNvSpPr/>
+          <p:nvPr/>
+        </p:nvSpPr>
+        <p:spPr>
+          <a:xfrm>
+            <a:off x="3447288" y="2286000"/>
+            <a:ext cx="2249424" cy="274320"/>
           </a:xfrm>
           <a:prstGeom prst="rect">
             <a:avLst/>
@@ -3725,7 +3839,7 @@
               <a:buNone/>
             </a:pPr>
             <a:r>
-              <a:rPr lang="en-US" sz="1000" dirty="0">
+              <a:rPr lang="en-US" sz="900" dirty="0">
                 <a:solidFill>
                   <a:srgbClr val="94A3B8"/>
                 </a:solidFill>
@@ -3733,16 +3847,16 @@
                 <a:ea typeface="Calibri" pitchFamily="34" charset="-122"/>
                 <a:cs typeface="Calibri" pitchFamily="34" charset="-120"/>
               </a:rPr>
-              <a:t>6.0 min avg vs 4.7 min</a:t>
-            </a:r>
-            <a:endParaRPr lang="en-US" sz="1000" dirty="0"/>
+              <a:t>caused by wrong tool</a:t>
+            </a:r>
+            <a:endParaRPr lang="en-US" sz="900" dirty="0"/>
           </a:p>
           <a:p>
             <a:pPr algn="ctr" indent="0" marL="0">
               <a:buNone/>
             </a:pPr>
             <a:r>
-              <a:rPr lang="en-US" sz="1000" dirty="0">
+              <a:rPr lang="en-US" sz="900" dirty="0">
                 <a:solidFill>
                   <a:srgbClr val="94A3B8"/>
                 </a:solidFill>
@@ -3750,27 +3864,64 @@
                 <a:ea typeface="Calibri" pitchFamily="34" charset="-122"/>
                 <a:cs typeface="Calibri" pitchFamily="34" charset="-120"/>
               </a:rPr>
-              <a:t>with correct diagnosis</a:t>
-            </a:r>
-            <a:endParaRPr lang="en-US" sz="1000" dirty="0"/>
-          </a:p>
-        </p:txBody>
-      </p:sp>
-      <p:sp>
-        <p:nvSpPr>
-          <p:cNvPr id="13" name="Shape 11"/>
-          <p:cNvSpPr/>
-          <p:nvPr/>
-        </p:nvSpPr>
-        <p:spPr>
-          <a:xfrm>
-            <a:off x="6263640" y="1371600"/>
-            <a:ext cx="2468880" cy="1417320"/>
-          </a:xfrm>
-          <a:prstGeom prst="rect">
-            <a:avLst>
-              <a:gd name="adj" fmla="val 5161"/>
-            </a:avLst>
+              <a:t>or action in production</a:t>
+            </a:r>
+            <a:endParaRPr lang="en-US" sz="900" dirty="0"/>
+          </a:p>
+        </p:txBody>
+      </p:sp>
+      <p:sp>
+        <p:nvSpPr>
+          <p:cNvPr id="17" name="Text 15"/>
+          <p:cNvSpPr/>
+          <p:nvPr/>
+        </p:nvSpPr>
+        <p:spPr>
+          <a:xfrm>
+            <a:off x="3447288" y="2587752"/>
+            <a:ext cx="2249424" cy="146304"/>
+          </a:xfrm>
+          <a:prstGeom prst="rect">
+            <a:avLst/>
+          </a:prstGeom>
+          <a:noFill/>
+          <a:ln/>
+        </p:spPr>
+        <p:txBody>
+          <a:bodyPr wrap="square" lIns="0" tIns="0" rIns="0" bIns="0" rtlCol="0" anchor="ctr"/>
+          <a:lstStyle/>
+          <a:p>
+            <a:pPr algn="ctr" indent="0" marL="0">
+              <a:buNone/>
+            </a:pPr>
+            <a:r>
+              <a:rPr lang="en-US" sz="800" i="1" dirty="0">
+                <a:solidFill>
+                  <a:srgbClr val="FBBF24"/>
+                </a:solidFill>
+                <a:latin typeface="Calibri" pitchFamily="34" charset="0"/>
+                <a:ea typeface="Calibri" pitchFamily="34" charset="-122"/>
+                <a:cs typeface="Calibri" pitchFamily="34" charset="-120"/>
+              </a:rPr>
+              <a:t>Trantornic, 2024-25</a:t>
+            </a:r>
+            <a:endParaRPr lang="en-US" sz="800" dirty="0"/>
+          </a:p>
+        </p:txBody>
+      </p:sp>
+      <p:sp>
+        <p:nvSpPr>
+          <p:cNvPr id="18" name="Shape 16"/>
+          <p:cNvSpPr/>
+          <p:nvPr/>
+        </p:nvSpPr>
+        <p:spPr>
+          <a:xfrm>
+            <a:off x="6263640" y="1508760"/>
+            <a:ext cx="2468880" cy="1261872"/>
+          </a:xfrm>
+          <a:prstGeom prst="rect">
+            <a:avLst/>
           </a:prstGeom>
           <a:solidFill>
             <a:srgbClr val="131D30"/>
@@ -3780,14 +3931,34 @@
       </p:sp>
       <p:sp>
         <p:nvSpPr>
-          <p:cNvPr id="14" name="Text 12"/>
-          <p:cNvSpPr/>
-          <p:nvPr/>
-        </p:nvSpPr>
-        <p:spPr>
-          <a:xfrm>
-            <a:off x="6428232" y="1499616"/>
-            <a:ext cx="2139696" cy="640080"/>
+          <p:cNvPr id="19" name="Shape 17"/>
+          <p:cNvSpPr/>
+          <p:nvPr/>
+        </p:nvSpPr>
+        <p:spPr>
+          <a:xfrm>
+            <a:off x="6263640" y="1508760"/>
+            <a:ext cx="2468880" cy="45720"/>
+          </a:xfrm>
+          <a:prstGeom prst="rect">
+            <a:avLst/>
+          </a:prstGeom>
+          <a:solidFill>
+            <a:srgbClr val="34D399"/>
+          </a:solidFill>
+          <a:ln/>
+        </p:spPr>
+      </p:sp>
+      <p:sp>
+        <p:nvSpPr>
+          <p:cNvPr id="20" name="Text 18"/>
+          <p:cNvSpPr/>
+          <p:nvPr/>
+        </p:nvSpPr>
+        <p:spPr>
+          <a:xfrm>
+            <a:off x="6373368" y="1600200"/>
+            <a:ext cx="2249424" cy="475488"/>
           </a:xfrm>
           <a:prstGeom prst="rect">
             <a:avLst/>
@@ -3803,7 +3974,85 @@
               <a:buNone/>
             </a:pPr>
             <a:r>
-              <a:rPr lang="en-US" sz="3600" b="1" dirty="0">
+              <a:rPr lang="en-US" sz="3000" b="1" dirty="0">
+                <a:solidFill>
+                  <a:srgbClr val="34D399"/>
+                </a:solidFill>
+                <a:latin typeface="Calibri" pitchFamily="34" charset="0"/>
+                <a:ea typeface="Calibri" pitchFamily="34" charset="-122"/>
+                <a:cs typeface="Calibri" pitchFamily="34" charset="-120"/>
+              </a:rPr>
+              <a:t>40%</a:t>
+            </a:r>
+            <a:endParaRPr lang="en-US" sz="3000" dirty="0"/>
+          </a:p>
+        </p:txBody>
+      </p:sp>
+      <p:sp>
+        <p:nvSpPr>
+          <p:cNvPr id="21" name="Text 19"/>
+          <p:cNvSpPr/>
+          <p:nvPr/>
+        </p:nvSpPr>
+        <p:spPr>
+          <a:xfrm>
+            <a:off x="6373368" y="2075688"/>
+            <a:ext cx="2249424" cy="219456"/>
+          </a:xfrm>
+          <a:prstGeom prst="rect">
+            <a:avLst/>
+          </a:prstGeom>
+          <a:noFill/>
+          <a:ln/>
+        </p:spPr>
+        <p:txBody>
+          <a:bodyPr wrap="square" lIns="0" tIns="0" rIns="0" bIns="0" rtlCol="0" anchor="ctr"/>
+          <a:lstStyle/>
+          <a:p>
+            <a:pPr algn="ctr" indent="0" marL="0">
+              <a:buNone/>
+            </a:pPr>
+            <a:r>
+              <a:rPr lang="en-US" sz="1100" b="1" dirty="0">
+                <a:solidFill>
+                  <a:srgbClr val="FFFFFF"/>
+                </a:solidFill>
+                <a:latin typeface="Calibri" pitchFamily="34" charset="0"/>
+                <a:ea typeface="Calibri" pitchFamily="34" charset="-122"/>
+                <a:cs typeface="Calibri" pitchFamily="34" charset="-120"/>
+              </a:rPr>
+              <a:t>MTTR Reduction</a:t>
+            </a:r>
+            <a:endParaRPr lang="en-US" sz="1100" dirty="0"/>
+          </a:p>
+        </p:txBody>
+      </p:sp>
+      <p:sp>
+        <p:nvSpPr>
+          <p:cNvPr id="22" name="Text 20"/>
+          <p:cNvSpPr/>
+          <p:nvPr/>
+        </p:nvSpPr>
+        <p:spPr>
+          <a:xfrm>
+            <a:off x="6373368" y="2286000"/>
+            <a:ext cx="2249424" cy="274320"/>
+          </a:xfrm>
+          <a:prstGeom prst="rect">
+            <a:avLst/>
+          </a:prstGeom>
+          <a:noFill/>
+          <a:ln/>
+        </p:spPr>
+        <p:txBody>
+          <a:bodyPr wrap="square" lIns="0" tIns="0" rIns="0" bIns="0" rtlCol="0" anchor="ctr"/>
+          <a:lstStyle/>
+          <a:p>
+            <a:pPr algn="ctr" indent="0" marL="0">
+              <a:buNone/>
+            </a:pPr>
+            <a:r>
+              <a:rPr lang="en-US" sz="900" dirty="0">
                 <a:solidFill>
                   <a:srgbClr val="94A3B8"/>
                 </a:solidFill>
@@ -3811,61 +4060,39 @@
                 <a:ea typeface="Calibri" pitchFamily="34" charset="-122"/>
                 <a:cs typeface="Calibri" pitchFamily="34" charset="-120"/>
               </a:rPr>
-              <a:t>0</a:t>
-            </a:r>
-            <a:endParaRPr lang="en-US" sz="3600" dirty="0"/>
-          </a:p>
-        </p:txBody>
-      </p:sp>
-      <p:sp>
-        <p:nvSpPr>
-          <p:cNvPr id="15" name="Text 13"/>
-          <p:cNvSpPr/>
-          <p:nvPr/>
-        </p:nvSpPr>
-        <p:spPr>
-          <a:xfrm>
-            <a:off x="6373368" y="2084832"/>
-            <a:ext cx="2249424" cy="256032"/>
-          </a:xfrm>
-          <a:prstGeom prst="rect">
-            <a:avLst/>
-          </a:prstGeom>
-          <a:noFill/>
-          <a:ln/>
-        </p:spPr>
-        <p:txBody>
-          <a:bodyPr wrap="square" lIns="0" tIns="0" rIns="0" bIns="0" rtlCol="0" anchor="ctr"/>
-          <a:lstStyle/>
+              <a:t>achievable when AI</a:t>
+            </a:r>
+            <a:endParaRPr lang="en-US" sz="900" dirty="0"/>
+          </a:p>
           <a:p>
             <a:pPr algn="ctr" indent="0" marL="0">
               <a:buNone/>
             </a:pPr>
             <a:r>
-              <a:rPr lang="en-US" sz="1200" b="1" dirty="0">
-                <a:solidFill>
-                  <a:srgbClr val="FFFFFF"/>
-                </a:solidFill>
-                <a:latin typeface="Calibri" pitchFamily="34" charset="0"/>
-                <a:ea typeface="Calibri" pitchFamily="34" charset="-122"/>
-                <a:cs typeface="Calibri" pitchFamily="34" charset="-120"/>
-              </a:rPr>
-              <a:t>Corrections Retained</a:t>
-            </a:r>
-            <a:endParaRPr lang="en-US" sz="1200" dirty="0"/>
-          </a:p>
-        </p:txBody>
-      </p:sp>
-      <p:sp>
-        <p:nvSpPr>
-          <p:cNvPr id="16" name="Text 14"/>
-          <p:cNvSpPr/>
-          <p:nvPr/>
-        </p:nvSpPr>
-        <p:spPr>
-          <a:xfrm>
-            <a:off x="6373368" y="2322576"/>
-            <a:ext cx="2249424" cy="256032"/>
+              <a:rPr lang="en-US" sz="900" dirty="0">
+                <a:solidFill>
+                  <a:srgbClr val="94A3B8"/>
+                </a:solidFill>
+                <a:latin typeface="Calibri" pitchFamily="34" charset="0"/>
+                <a:ea typeface="Calibri" pitchFamily="34" charset="-122"/>
+                <a:cs typeface="Calibri" pitchFamily="34" charset="-120"/>
+              </a:rPr>
+              <a:t>automation is correct</a:t>
+            </a:r>
+            <a:endParaRPr lang="en-US" sz="900" dirty="0"/>
+          </a:p>
+        </p:txBody>
+      </p:sp>
+      <p:sp>
+        <p:nvSpPr>
+          <p:cNvPr id="23" name="Text 21"/>
+          <p:cNvSpPr/>
+          <p:nvPr/>
+        </p:nvSpPr>
+        <p:spPr>
+          <a:xfrm>
+            <a:off x="6373368" y="2587752"/>
+            <a:ext cx="2249424" cy="146304"/>
           </a:xfrm>
           <a:prstGeom prst="rect">
             <a:avLst/>
@@ -3881,47 +4108,69 @@
               <a:buNone/>
             </a:pPr>
             <a:r>
-              <a:rPr lang="en-US" sz="1000" dirty="0">
-                <a:solidFill>
-                  <a:srgbClr val="94A3B8"/>
-                </a:solidFill>
-                <a:latin typeface="Calibri" pitchFamily="34" charset="0"/>
-                <a:ea typeface="Calibri" pitchFamily="34" charset="-122"/>
-                <a:cs typeface="Calibri" pitchFamily="34" charset="-120"/>
-              </a:rPr>
-              <a:t>today's agents forget every</a:t>
-            </a:r>
-            <a:endParaRPr lang="en-US" sz="1000" dirty="0"/>
-          </a:p>
-          <a:p>
-            <a:pPr algn="ctr" indent="0" marL="0">
-              <a:buNone/>
-            </a:pPr>
-            <a:r>
-              <a:rPr lang="en-US" sz="1000" dirty="0">
-                <a:solidFill>
-                  <a:srgbClr val="94A3B8"/>
-                </a:solidFill>
-                <a:latin typeface="Calibri" pitchFamily="34" charset="0"/>
-                <a:ea typeface="Calibri" pitchFamily="34" charset="-122"/>
-                <a:cs typeface="Calibri" pitchFamily="34" charset="-120"/>
-              </a:rPr>
-              <a:t>override when context closes</a:t>
-            </a:r>
-            <a:endParaRPr lang="en-US" sz="1000" dirty="0"/>
-          </a:p>
-        </p:txBody>
-      </p:sp>
-      <p:sp>
-        <p:nvSpPr>
-          <p:cNvPr id="17" name="Shape 15"/>
-          <p:cNvSpPr/>
-          <p:nvPr/>
-        </p:nvSpPr>
-        <p:spPr>
-          <a:xfrm>
-            <a:off x="411480" y="2971800"/>
-            <a:ext cx="8321040" cy="1051560"/>
+              <a:rPr lang="en-US" sz="800" i="1" dirty="0">
+                <a:solidFill>
+                  <a:srgbClr val="34D399"/>
+                </a:solidFill>
+                <a:latin typeface="Calibri" pitchFamily="34" charset="0"/>
+                <a:ea typeface="Calibri" pitchFamily="34" charset="-122"/>
+                <a:cs typeface="Calibri" pitchFamily="34" charset="-120"/>
+              </a:rPr>
+              <a:t>Rootly, 2025</a:t>
+            </a:r>
+            <a:endParaRPr lang="en-US" sz="800" dirty="0"/>
+          </a:p>
+        </p:txBody>
+      </p:sp>
+      <p:sp>
+        <p:nvSpPr>
+          <p:cNvPr id="24" name="Text 22"/>
+          <p:cNvSpPr/>
+          <p:nvPr/>
+        </p:nvSpPr>
+        <p:spPr>
+          <a:xfrm>
+            <a:off x="411480" y="2907792"/>
+            <a:ext cx="4572000" cy="201168"/>
+          </a:xfrm>
+          <a:prstGeom prst="rect">
+            <a:avLst/>
+          </a:prstGeom>
+          <a:noFill/>
+          <a:ln/>
+        </p:spPr>
+        <p:txBody>
+          <a:bodyPr wrap="square" lIns="0" tIns="0" rIns="0" bIns="0" rtlCol="0" anchor="ctr"/>
+          <a:lstStyle/>
+          <a:p>
+            <a:pPr indent="0" marL="0">
+              <a:buNone/>
+            </a:pPr>
+            <a:r>
+              <a:rPr lang="en-US" sz="800" b="1" spc="200" kern="0" dirty="0">
+                <a:solidFill>
+                  <a:srgbClr val="38BDF8"/>
+                </a:solidFill>
+                <a:latin typeface="Calibri" pitchFamily="34" charset="0"/>
+                <a:ea typeface="Calibri" pitchFamily="34" charset="-122"/>
+                <a:cs typeface="Calibri" pitchFamily="34" charset="-120"/>
+              </a:rPr>
+              <a:t>INFRABRAIN  (120 live Gemini 3.5 Flash calls)</a:t>
+            </a:r>
+            <a:endParaRPr lang="en-US" sz="800" dirty="0"/>
+          </a:p>
+        </p:txBody>
+      </p:sp>
+      <p:sp>
+        <p:nvSpPr>
+          <p:cNvPr id="25" name="Shape 23"/>
+          <p:cNvSpPr/>
+          <p:nvPr/>
+        </p:nvSpPr>
+        <p:spPr>
+          <a:xfrm>
+            <a:off x="411480" y="3108960"/>
+            <a:ext cx="2468880" cy="1005840"/>
           </a:xfrm>
           <a:prstGeom prst="rect">
             <a:avLst/>
@@ -3929,24 +4178,410 @@
           <a:solidFill>
             <a:srgbClr val="1A2640"/>
           </a:solidFill>
-          <a:ln w="12700">
-            <a:solidFill>
-              <a:srgbClr val="818CF8"/>
-            </a:solidFill>
-            <a:prstDash val="solid"/>
-          </a:ln>
-        </p:spPr>
-      </p:sp>
-      <p:sp>
-        <p:nvSpPr>
-          <p:cNvPr id="18" name="Text 16"/>
-          <p:cNvSpPr/>
-          <p:nvPr/>
-        </p:nvSpPr>
-        <p:spPr>
-          <a:xfrm>
-            <a:off x="594360" y="3063240"/>
-            <a:ext cx="3657600" cy="274320"/>
+          <a:ln/>
+        </p:spPr>
+      </p:sp>
+      <p:sp>
+        <p:nvSpPr>
+          <p:cNvPr id="26" name="Text 24"/>
+          <p:cNvSpPr/>
+          <p:nvPr/>
+        </p:nvSpPr>
+        <p:spPr>
+          <a:xfrm>
+            <a:off x="521208" y="3163824"/>
+            <a:ext cx="2249424" cy="402336"/>
+          </a:xfrm>
+          <a:prstGeom prst="rect">
+            <a:avLst/>
+          </a:prstGeom>
+          <a:noFill/>
+          <a:ln/>
+        </p:spPr>
+        <p:txBody>
+          <a:bodyPr wrap="square" lIns="0" tIns="0" rIns="0" bIns="0" rtlCol="0" anchor="ctr"/>
+          <a:lstStyle/>
+          <a:p>
+            <a:pPr algn="ctr" indent="0" marL="0">
+              <a:buNone/>
+            </a:pPr>
+            <a:r>
+              <a:rPr lang="en-US" sz="2600" b="1" dirty="0">
+                <a:solidFill>
+                  <a:srgbClr val="F87171"/>
+                </a:solidFill>
+                <a:latin typeface="Calibri" pitchFamily="34" charset="0"/>
+                <a:ea typeface="Calibri" pitchFamily="34" charset="-122"/>
+                <a:cs typeface="Calibri" pitchFamily="34" charset="-120"/>
+              </a:rPr>
+              <a:t>30%</a:t>
+            </a:r>
+            <a:endParaRPr lang="en-US" sz="2600" dirty="0"/>
+          </a:p>
+        </p:txBody>
+      </p:sp>
+      <p:sp>
+        <p:nvSpPr>
+          <p:cNvPr id="27" name="Text 25"/>
+          <p:cNvSpPr/>
+          <p:nvPr/>
+        </p:nvSpPr>
+        <p:spPr>
+          <a:xfrm>
+            <a:off x="521208" y="3566160"/>
+            <a:ext cx="2249424" cy="219456"/>
+          </a:xfrm>
+          <a:prstGeom prst="rect">
+            <a:avLst/>
+          </a:prstGeom>
+          <a:noFill/>
+          <a:ln/>
+        </p:spPr>
+        <p:txBody>
+          <a:bodyPr wrap="square" lIns="0" tIns="0" rIns="0" bIns="0" rtlCol="0" anchor="ctr"/>
+          <a:lstStyle/>
+          <a:p>
+            <a:pPr algn="ctr" indent="0" marL="0">
+              <a:buNone/>
+            </a:pPr>
+            <a:r>
+              <a:rPr lang="en-US" sz="1100" b="1" dirty="0">
+                <a:solidFill>
+                  <a:srgbClr val="FFFFFF"/>
+                </a:solidFill>
+                <a:latin typeface="Calibri" pitchFamily="34" charset="0"/>
+                <a:ea typeface="Calibri" pitchFamily="34" charset="-122"/>
+                <a:cs typeface="Calibri" pitchFamily="34" charset="-120"/>
+              </a:rPr>
+              <a:t>Faults Misdiagnosed</a:t>
+            </a:r>
+            <a:endParaRPr lang="en-US" sz="1100" dirty="0"/>
+          </a:p>
+        </p:txBody>
+      </p:sp>
+      <p:sp>
+        <p:nvSpPr>
+          <p:cNvPr id="28" name="Text 26"/>
+          <p:cNvSpPr/>
+          <p:nvPr/>
+        </p:nvSpPr>
+        <p:spPr>
+          <a:xfrm>
+            <a:off x="521208" y="3785616"/>
+            <a:ext cx="2249424" cy="256032"/>
+          </a:xfrm>
+          <a:prstGeom prst="rect">
+            <a:avLst/>
+          </a:prstGeom>
+          <a:noFill/>
+          <a:ln/>
+        </p:spPr>
+        <p:txBody>
+          <a:bodyPr wrap="square" lIns="0" tIns="0" rIns="0" bIns="0" rtlCol="0" anchor="ctr"/>
+          <a:lstStyle/>
+          <a:p>
+            <a:pPr algn="ctr" indent="0" marL="0">
+              <a:buNone/>
+            </a:pPr>
+            <a:r>
+              <a:rPr lang="en-US" sz="900" dirty="0">
+                <a:solidFill>
+                  <a:srgbClr val="94A3B8"/>
+                </a:solidFill>
+                <a:latin typeface="Calibri" pitchFamily="34" charset="0"/>
+                <a:ea typeface="Calibri" pitchFamily="34" charset="-122"/>
+                <a:cs typeface="Calibri" pitchFamily="34" charset="-120"/>
+              </a:rPr>
+              <a:t>at gen-0 baseline, no KG context</a:t>
+            </a:r>
+            <a:endParaRPr lang="en-US" sz="900" dirty="0"/>
+          </a:p>
+        </p:txBody>
+      </p:sp>
+      <p:sp>
+        <p:nvSpPr>
+          <p:cNvPr id="29" name="Shape 27"/>
+          <p:cNvSpPr/>
+          <p:nvPr/>
+        </p:nvSpPr>
+        <p:spPr>
+          <a:xfrm>
+            <a:off x="3337560" y="3108960"/>
+            <a:ext cx="2468880" cy="1005840"/>
+          </a:xfrm>
+          <a:prstGeom prst="rect">
+            <a:avLst/>
+          </a:prstGeom>
+          <a:solidFill>
+            <a:srgbClr val="1A2640"/>
+          </a:solidFill>
+          <a:ln/>
+        </p:spPr>
+      </p:sp>
+      <p:sp>
+        <p:nvSpPr>
+          <p:cNvPr id="30" name="Text 28"/>
+          <p:cNvSpPr/>
+          <p:nvPr/>
+        </p:nvSpPr>
+        <p:spPr>
+          <a:xfrm>
+            <a:off x="3447288" y="3163824"/>
+            <a:ext cx="2249424" cy="402336"/>
+          </a:xfrm>
+          <a:prstGeom prst="rect">
+            <a:avLst/>
+          </a:prstGeom>
+          <a:noFill/>
+          <a:ln/>
+        </p:spPr>
+        <p:txBody>
+          <a:bodyPr wrap="square" lIns="0" tIns="0" rIns="0" bIns="0" rtlCol="0" anchor="ctr"/>
+          <a:lstStyle/>
+          <a:p>
+            <a:pPr algn="ctr" indent="0" marL="0">
+              <a:buNone/>
+            </a:pPr>
+            <a:r>
+              <a:rPr lang="en-US" sz="2600" b="1" dirty="0">
+                <a:solidFill>
+                  <a:srgbClr val="FBBF24"/>
+                </a:solidFill>
+                <a:latin typeface="Calibri" pitchFamily="34" charset="0"/>
+                <a:ea typeface="Calibri" pitchFamily="34" charset="-122"/>
+                <a:cs typeface="Calibri" pitchFamily="34" charset="-120"/>
+              </a:rPr>
+              <a:t>1.3 min</a:t>
+            </a:r>
+            <a:endParaRPr lang="en-US" sz="2600" dirty="0"/>
+          </a:p>
+        </p:txBody>
+      </p:sp>
+      <p:sp>
+        <p:nvSpPr>
+          <p:cNvPr id="31" name="Text 29"/>
+          <p:cNvSpPr/>
+          <p:nvPr/>
+        </p:nvSpPr>
+        <p:spPr>
+          <a:xfrm>
+            <a:off x="3447288" y="3566160"/>
+            <a:ext cx="2249424" cy="219456"/>
+          </a:xfrm>
+          <a:prstGeom prst="rect">
+            <a:avLst/>
+          </a:prstGeom>
+          <a:noFill/>
+          <a:ln/>
+        </p:spPr>
+        <p:txBody>
+          <a:bodyPr wrap="square" lIns="0" tIns="0" rIns="0" bIns="0" rtlCol="0" anchor="ctr"/>
+          <a:lstStyle/>
+          <a:p>
+            <a:pPr algn="ctr" indent="0" marL="0">
+              <a:buNone/>
+            </a:pPr>
+            <a:r>
+              <a:rPr lang="en-US" sz="1100" b="1" dirty="0">
+                <a:solidFill>
+                  <a:srgbClr val="FFFFFF"/>
+                </a:solidFill>
+                <a:latin typeface="Calibri" pitchFamily="34" charset="0"/>
+                <a:ea typeface="Calibri" pitchFamily="34" charset="-122"/>
+                <a:cs typeface="Calibri" pitchFamily="34" charset="-120"/>
+              </a:rPr>
+              <a:t>Wasted Per Fault</a:t>
+            </a:r>
+            <a:endParaRPr lang="en-US" sz="1100" dirty="0"/>
+          </a:p>
+        </p:txBody>
+      </p:sp>
+      <p:sp>
+        <p:nvSpPr>
+          <p:cNvPr id="32" name="Text 30"/>
+          <p:cNvSpPr/>
+          <p:nvPr/>
+        </p:nvSpPr>
+        <p:spPr>
+          <a:xfrm>
+            <a:off x="3447288" y="3785616"/>
+            <a:ext cx="2249424" cy="256032"/>
+          </a:xfrm>
+          <a:prstGeom prst="rect">
+            <a:avLst/>
+          </a:prstGeom>
+          <a:noFill/>
+          <a:ln/>
+        </p:spPr>
+        <p:txBody>
+          <a:bodyPr wrap="square" lIns="0" tIns="0" rIns="0" bIns="0" rtlCol="0" anchor="ctr"/>
+          <a:lstStyle/>
+          <a:p>
+            <a:pPr algn="ctr" indent="0" marL="0">
+              <a:buNone/>
+            </a:pPr>
+            <a:r>
+              <a:rPr lang="en-US" sz="900" dirty="0">
+                <a:solidFill>
+                  <a:srgbClr val="94A3B8"/>
+                </a:solidFill>
+                <a:latin typeface="Calibri" pitchFamily="34" charset="0"/>
+                <a:ea typeface="Calibri" pitchFamily="34" charset="-122"/>
+                <a:cs typeface="Calibri" pitchFamily="34" charset="-120"/>
+              </a:rPr>
+              <a:t>6.0 min vs 4.7 min with correct fix</a:t>
+            </a:r>
+            <a:endParaRPr lang="en-US" sz="900" dirty="0"/>
+          </a:p>
+        </p:txBody>
+      </p:sp>
+      <p:sp>
+        <p:nvSpPr>
+          <p:cNvPr id="33" name="Shape 31"/>
+          <p:cNvSpPr/>
+          <p:nvPr/>
+        </p:nvSpPr>
+        <p:spPr>
+          <a:xfrm>
+            <a:off x="6263640" y="3108960"/>
+            <a:ext cx="2468880" cy="1005840"/>
+          </a:xfrm>
+          <a:prstGeom prst="rect">
+            <a:avLst/>
+          </a:prstGeom>
+          <a:solidFill>
+            <a:srgbClr val="1A2640"/>
+          </a:solidFill>
+          <a:ln/>
+        </p:spPr>
+      </p:sp>
+      <p:sp>
+        <p:nvSpPr>
+          <p:cNvPr id="34" name="Text 32"/>
+          <p:cNvSpPr/>
+          <p:nvPr/>
+        </p:nvSpPr>
+        <p:spPr>
+          <a:xfrm>
+            <a:off x="6373368" y="3163824"/>
+            <a:ext cx="2249424" cy="402336"/>
+          </a:xfrm>
+          <a:prstGeom prst="rect">
+            <a:avLst/>
+          </a:prstGeom>
+          <a:noFill/>
+          <a:ln/>
+        </p:spPr>
+        <p:txBody>
+          <a:bodyPr wrap="square" lIns="0" tIns="0" rIns="0" bIns="0" rtlCol="0" anchor="ctr"/>
+          <a:lstStyle/>
+          <a:p>
+            <a:pPr algn="ctr" indent="0" marL="0">
+              <a:buNone/>
+            </a:pPr>
+            <a:r>
+              <a:rPr lang="en-US" sz="2600" b="1" dirty="0">
+                <a:solidFill>
+                  <a:srgbClr val="94A3B8"/>
+                </a:solidFill>
+                <a:latin typeface="Calibri" pitchFamily="34" charset="0"/>
+                <a:ea typeface="Calibri" pitchFamily="34" charset="-122"/>
+                <a:cs typeface="Calibri" pitchFamily="34" charset="-120"/>
+              </a:rPr>
+              <a:t>0</a:t>
+            </a:r>
+            <a:endParaRPr lang="en-US" sz="2600" dirty="0"/>
+          </a:p>
+        </p:txBody>
+      </p:sp>
+      <p:sp>
+        <p:nvSpPr>
+          <p:cNvPr id="35" name="Text 33"/>
+          <p:cNvSpPr/>
+          <p:nvPr/>
+        </p:nvSpPr>
+        <p:spPr>
+          <a:xfrm>
+            <a:off x="6373368" y="3566160"/>
+            <a:ext cx="2249424" cy="219456"/>
+          </a:xfrm>
+          <a:prstGeom prst="rect">
+            <a:avLst/>
+          </a:prstGeom>
+          <a:noFill/>
+          <a:ln/>
+        </p:spPr>
+        <p:txBody>
+          <a:bodyPr wrap="square" lIns="0" tIns="0" rIns="0" bIns="0" rtlCol="0" anchor="ctr"/>
+          <a:lstStyle/>
+          <a:p>
+            <a:pPr algn="ctr" indent="0" marL="0">
+              <a:buNone/>
+            </a:pPr>
+            <a:r>
+              <a:rPr lang="en-US" sz="1100" b="1" dirty="0">
+                <a:solidFill>
+                  <a:srgbClr val="FFFFFF"/>
+                </a:solidFill>
+                <a:latin typeface="Calibri" pitchFamily="34" charset="0"/>
+                <a:ea typeface="Calibri" pitchFamily="34" charset="-122"/>
+                <a:cs typeface="Calibri" pitchFamily="34" charset="-120"/>
+              </a:rPr>
+              <a:t>Corrections Retained</a:t>
+            </a:r>
+            <a:endParaRPr lang="en-US" sz="1100" dirty="0"/>
+          </a:p>
+        </p:txBody>
+      </p:sp>
+      <p:sp>
+        <p:nvSpPr>
+          <p:cNvPr id="36" name="Text 34"/>
+          <p:cNvSpPr/>
+          <p:nvPr/>
+        </p:nvSpPr>
+        <p:spPr>
+          <a:xfrm>
+            <a:off x="6373368" y="3785616"/>
+            <a:ext cx="2249424" cy="256032"/>
+          </a:xfrm>
+          <a:prstGeom prst="rect">
+            <a:avLst/>
+          </a:prstGeom>
+          <a:noFill/>
+          <a:ln/>
+        </p:spPr>
+        <p:txBody>
+          <a:bodyPr wrap="square" lIns="0" tIns="0" rIns="0" bIns="0" rtlCol="0" anchor="ctr"/>
+          <a:lstStyle/>
+          <a:p>
+            <a:pPr algn="ctr" indent="0" marL="0">
+              <a:buNone/>
+            </a:pPr>
+            <a:r>
+              <a:rPr lang="en-US" sz="900" dirty="0">
+                <a:solidFill>
+                  <a:srgbClr val="94A3B8"/>
+                </a:solidFill>
+                <a:latin typeface="Calibri" pitchFamily="34" charset="0"/>
+                <a:ea typeface="Calibri" pitchFamily="34" charset="-122"/>
+                <a:cs typeface="Calibri" pitchFamily="34" charset="-120"/>
+              </a:rPr>
+              <a:t>stateless agents forget every override</a:t>
+            </a:r>
+            <a:endParaRPr lang="en-US" sz="900" dirty="0"/>
+          </a:p>
+        </p:txBody>
+      </p:sp>
+      <p:sp>
+        <p:nvSpPr>
+          <p:cNvPr id="37" name="Text 35"/>
+          <p:cNvSpPr/>
+          <p:nvPr/>
+        </p:nvSpPr>
+        <p:spPr>
+          <a:xfrm>
+            <a:off x="411480" y="4864608"/>
+            <a:ext cx="8321040" cy="164592"/>
           </a:xfrm>
           <a:prstGeom prst="rect">
             <a:avLst/>
@@ -3962,85 +4597,7 @@
               <a:buNone/>
             </a:pPr>
             <a:r>
-              <a:rPr lang="en-US" sz="1300" b="1" dirty="0">
-                <a:solidFill>
-                  <a:srgbClr val="818CF8"/>
-                </a:solidFill>
-                <a:latin typeface="Calibri" pitchFamily="34" charset="0"/>
-                <a:ea typeface="Calibri" pitchFamily="34" charset="-122"/>
-                <a:cs typeface="Calibri" pitchFamily="34" charset="-120"/>
-              </a:rPr>
-              <a:t>The deeper problem</a:t>
-            </a:r>
-            <a:endParaRPr lang="en-US" sz="1300" dirty="0"/>
-          </a:p>
-        </p:txBody>
-      </p:sp>
-      <p:sp>
-        <p:nvSpPr>
-          <p:cNvPr id="19" name="Text 17"/>
-          <p:cNvSpPr/>
-          <p:nvPr/>
-        </p:nvSpPr>
-        <p:spPr>
-          <a:xfrm>
-            <a:off x="594360" y="3364992"/>
-            <a:ext cx="7955280" cy="594360"/>
-          </a:xfrm>
-          <a:prstGeom prst="rect">
-            <a:avLst/>
-          </a:prstGeom>
-          <a:noFill/>
-          <a:ln/>
-        </p:spPr>
-        <p:txBody>
-          <a:bodyPr wrap="square" lIns="0" tIns="0" rIns="0" bIns="0" rtlCol="0" anchor="ctr"/>
-          <a:lstStyle/>
-          <a:p>
-            <a:pPr indent="0" marL="0">
-              <a:buNone/>
-            </a:pPr>
-            <a:r>
-              <a:rPr lang="en-US" sz="1200" dirty="0">
-                <a:solidFill>
-                  <a:srgbClr val="E2E8F0"/>
-                </a:solidFill>
-                <a:latin typeface="Calibri" pitchFamily="34" charset="0"/>
-                <a:ea typeface="Calibri" pitchFamily="34" charset="-122"/>
-                <a:cs typeface="Calibri" pitchFamily="34" charset="-120"/>
-              </a:rPr>
-              <a:t>Today's AI diagnostic agents are stateless. A fault is misdiagnosed → a human corrects it → the agent learns nothing. The next identical fault gets misdiagnosed again. The correction signal is lost. At GPU-cluster scale, this compounds into thousands of wasted SRE-hours and gigawatt-hours of unnecessary downtime.</a:t>
-            </a:r>
-            <a:endParaRPr lang="en-US" sz="1200" dirty="0"/>
-          </a:p>
-        </p:txBody>
-      </p:sp>
-      <p:sp>
-        <p:nvSpPr>
-          <p:cNvPr id="20" name="Text 18"/>
-          <p:cNvSpPr/>
-          <p:nvPr/>
-        </p:nvSpPr>
-        <p:spPr>
-          <a:xfrm>
-            <a:off x="411480" y="4828032"/>
-            <a:ext cx="8321040" cy="201168"/>
-          </a:xfrm>
-          <a:prstGeom prst="rect">
-            <a:avLst/>
-          </a:prstGeom>
-          <a:noFill/>
-          <a:ln/>
-        </p:spPr>
-        <p:txBody>
-          <a:bodyPr wrap="square" lIns="0" tIns="0" rIns="0" bIns="0" rtlCol="0" anchor="ctr"/>
-          <a:lstStyle/>
-          <a:p>
-            <a:pPr algn="r" indent="0" marL="0">
-              <a:buNone/>
-            </a:pPr>
-            <a:r>
-              <a:rPr lang="en-US" sz="900" dirty="0">
+              <a:rPr lang="en-US" sz="800" dirty="0">
                 <a:solidFill>
                   <a:srgbClr val="475569"/>
                 </a:solidFill>
@@ -4048,9 +4605,9 @@
                 <a:ea typeface="Calibri" pitchFamily="34" charset="-122"/>
                 <a:cs typeface="Calibri" pitchFamily="34" charset="-120"/>
               </a:rPr>
-              <a:t>Source: 120 live Gemini 3.5 Flash API calls · infrabrain-eval · July 2026</a:t>
-            </a:r>
-            <a:endParaRPr lang="en-US" sz="900" dirty="0"/>
+              <a:t>Sources: EMA Research 2024 · Trantornic 2024-25 · Rootly 2025 · infrabrain-eval (github.com/bbarathsrinivasan/InfraBrain)</a:t>
+            </a:r>
+            <a:endParaRPr lang="en-US" sz="800" dirty="0"/>
           </a:p>
         </p:txBody>
       </p:sp>

</xml_diff>

<commit_message>
feat: add Darwin Gödel Machine paper reference slide (slide 5)
- New slide between solution loops and results chart: full paper citation
  (arXiv 2503.19461, Sakana AI / Google DeepMind), dashed image placeholder
  for paper cover, and 4-row mapping table (paper concept → InfraBrain impl)
- Fixed title slide subtitle: was "GPU Diagnostic Agent", now matches project
  name "A Self-Improving Agent That Learns from Every Override"
- Updated SLIDES.md: slide count 6→7, new Slide 5 speaker notes with
  mapping table, updated talk-track timing

Co-Authored-By: Claude Sonnet 4.6 <noreply@anthropic.com>
</commit_message>
<xml_diff>
--- a/InfraBrain_Presentation.pptx
+++ b/InfraBrain_Presentation.pptx
@@ -11,9 +11,10 @@
     <p:sldId id="259" r:id="rId5"/>
     <p:sldId id="260" r:id="rId6"/>
     <p:sldId id="261" r:id="rId7"/>
+    <p:sldId id="262" r:id="rId8"/>
   </p:sldIdLst>
   <p:notesMasterIdLst>
-    <p:notesMasterId r:id="rId8"/>
+    <p:notesMasterId r:id="rId9"/>
   </p:notesMasterIdLst>
   <p:sldSz cx="9144000" cy="5143500"/>
   <p:notesSz cx="5143500" cy="9144000"/>
@@ -1397,6 +1398,94 @@
             <a:fld id="{F7021451-1387-4CA6-816F-3879F97B5CBC}" type="slidenum">
               <a:rPr lang="en-US"/>
               <a:t>6</a:t>
+            </a:fld>
+            <a:endParaRPr lang="en-US"/>
+          </a:p>
+        </p:txBody>
+      </p:sp>
+    </p:spTree>
+    <p:extLst>
+      <p:ext uri="{BB962C8B-B14F-4D97-AF65-F5344CB8AC3E}">
+        <p14:creationId xmlns:p14="http://schemas.microsoft.com/office/powerpoint/2010/main" val="1024086991"/>
+      </p:ext>
+    </p:extLst>
+  </p:cSld>
+  <p:clrMapOvr>
+    <a:masterClrMapping/>
+  </p:clrMapOvr>
+</p:notes>
+</file>
+
+<file path=ppt/notesSlides/notesSlide7.xml><?xml version="1.0" encoding="utf-8"?>
+<p:notes xmlns:a="http://schemas.openxmlformats.org/drawingml/2006/main" xmlns:r="http://schemas.openxmlformats.org/officeDocument/2006/relationships" xmlns:p="http://schemas.openxmlformats.org/presentationml/2006/main">
+  <p:cSld>
+    <p:spTree>
+      <p:nvGrpSpPr>
+        <p:cNvPr id="1" name=""/>
+        <p:cNvGrpSpPr/>
+        <p:nvPr/>
+      </p:nvGrpSpPr>
+      <p:grpSpPr>
+        <a:xfrm>
+          <a:off x="0" y="0"/>
+          <a:ext cx="0" cy="0"/>
+          <a:chOff x="0" y="0"/>
+          <a:chExt cx="0" cy="0"/>
+        </a:xfrm>
+      </p:grpSpPr>
+      <p:sp>
+        <p:nvSpPr>
+          <p:cNvPr id="2" name="Slide Image Placeholder 1"/>
+          <p:cNvSpPr>
+            <a:spLocks noGrp="1" noRot="1" noChangeAspect="1"/>
+          </p:cNvSpPr>
+          <p:nvPr>
+            <p:ph type="sldImg"/>
+          </p:nvPr>
+        </p:nvSpPr>
+        <p:spPr/>
+      </p:sp>
+      <p:sp>
+        <p:nvSpPr>
+          <p:cNvPr id="3" name="Notes Placeholder 2"/>
+          <p:cNvSpPr>
+            <a:spLocks noGrp="1"/>
+          </p:cNvSpPr>
+          <p:nvPr>
+            <p:ph type="body" idx="1"/>
+          </p:nvPr>
+        </p:nvSpPr>
+        <p:spPr/>
+        <p:txBody>
+          <a:bodyPr/>
+          <a:lstStyle/>
+          <a:p>
+            <a:r>
+              <a:rPr lang="en-US" dirty="0"/>
+              <a:t/>
+            </a:r>
+            <a:endParaRPr lang="en-US" dirty="0"/>
+          </a:p>
+        </p:txBody>
+      </p:sp>
+      <p:sp>
+        <p:nvSpPr>
+          <p:cNvPr id="4" name="Slide Number Placeholder 3"/>
+          <p:cNvSpPr>
+            <a:spLocks noGrp="1"/>
+          </p:cNvSpPr>
+          <p:nvPr>
+            <p:ph type="sldNum" sz="quarter" idx="10"/>
+          </p:nvPr>
+        </p:nvSpPr>
+        <p:spPr/>
+        <p:txBody>
+          <a:bodyPr/>
+          <a:lstStyle/>
+          <a:p>
+            <a:fld id="{F7021451-1387-4CA6-816F-3879F97B5CBC}" type="slidenum">
+              <a:rPr lang="en-US"/>
+              <a:t>7</a:t>
             </a:fld>
             <a:endParaRPr lang="en-US"/>
           </a:p>
@@ -2246,7 +2335,7 @@
                 <a:ea typeface="Calibri" pitchFamily="34" charset="-122"/>
                 <a:cs typeface="Calibri" pitchFamily="34" charset="-120"/>
               </a:rPr>
-              <a:t>A Self-Improving GPU Diagnostic Agent</a:t>
+              <a:t>A Self-Improving Agent That Learns from Every Override</a:t>
             </a:r>
             <a:endParaRPr lang="en-US" sz="2000" dirty="0"/>
           </a:p>
@@ -5576,6 +5665,1054 @@
                 <a:ea typeface="Calibri" pitchFamily="34" charset="-122"/>
                 <a:cs typeface="Calibri" pitchFamily="34" charset="-120"/>
               </a:rPr>
+              <a:t>PART 2  ·  THE PAPER BEHIND IT</a:t>
+            </a:r>
+            <a:endParaRPr lang="en-US" sz="900" dirty="0"/>
+          </a:p>
+        </p:txBody>
+      </p:sp>
+      <p:sp>
+        <p:nvSpPr>
+          <p:cNvPr id="4" name="Text 2"/>
+          <p:cNvSpPr/>
+          <p:nvPr/>
+        </p:nvSpPr>
+        <p:spPr>
+          <a:xfrm>
+            <a:off x="411480" y="548640"/>
+            <a:ext cx="5120640" cy="685800"/>
+          </a:xfrm>
+          <a:prstGeom prst="rect">
+            <a:avLst/>
+          </a:prstGeom>
+          <a:noFill/>
+          <a:ln/>
+        </p:spPr>
+        <p:txBody>
+          <a:bodyPr wrap="square" lIns="0" tIns="0" rIns="0" bIns="0" rtlCol="0" anchor="ctr"/>
+          <a:lstStyle/>
+          <a:p>
+            <a:pPr indent="0" marL="0">
+              <a:buNone/>
+            </a:pPr>
+            <a:r>
+              <a:rPr lang="en-US" sz="3600" b="1" dirty="0">
+                <a:solidFill>
+                  <a:srgbClr val="FFFFFF"/>
+                </a:solidFill>
+                <a:latin typeface="Calibri" pitchFamily="34" charset="0"/>
+                <a:ea typeface="Calibri" pitchFamily="34" charset="-122"/>
+                <a:cs typeface="Calibri" pitchFamily="34" charset="-120"/>
+              </a:rPr>
+              <a:t>Darwin Gödel Machine</a:t>
+            </a:r>
+            <a:endParaRPr lang="en-US" sz="3600" dirty="0"/>
+          </a:p>
+        </p:txBody>
+      </p:sp>
+      <p:sp>
+        <p:nvSpPr>
+          <p:cNvPr id="5" name="Shape 3"/>
+          <p:cNvSpPr/>
+          <p:nvPr/>
+        </p:nvSpPr>
+        <p:spPr>
+          <a:xfrm>
+            <a:off x="411480" y="1261872"/>
+            <a:ext cx="2103120" cy="274320"/>
+          </a:xfrm>
+          <a:prstGeom prst="rect">
+            <a:avLst/>
+          </a:prstGeom>
+          <a:solidFill>
+            <a:srgbClr val="818CF8">
+              <a:alpha val="80000"/>
+            </a:srgbClr>
+          </a:solidFill>
+          <a:ln/>
+        </p:spPr>
+      </p:sp>
+      <p:sp>
+        <p:nvSpPr>
+          <p:cNvPr id="6" name="Text 4"/>
+          <p:cNvSpPr/>
+          <p:nvPr/>
+        </p:nvSpPr>
+        <p:spPr>
+          <a:xfrm>
+            <a:off x="411480" y="1261872"/>
+            <a:ext cx="2103120" cy="274320"/>
+          </a:xfrm>
+          <a:prstGeom prst="rect">
+            <a:avLst/>
+          </a:prstGeom>
+          <a:noFill/>
+          <a:ln/>
+        </p:spPr>
+        <p:txBody>
+          <a:bodyPr wrap="square" lIns="0" tIns="0" rIns="0" bIns="0" rtlCol="0" anchor="ctr"/>
+          <a:lstStyle/>
+          <a:p>
+            <a:pPr algn="ctr" indent="0" marL="0">
+              <a:buNone/>
+            </a:pPr>
+            <a:r>
+              <a:rPr lang="en-US" sz="1000" b="1" dirty="0">
+                <a:solidFill>
+                  <a:srgbClr val="FFFFFF"/>
+                </a:solidFill>
+                <a:latin typeface="Calibri" pitchFamily="34" charset="0"/>
+                <a:ea typeface="Calibri" pitchFamily="34" charset="-122"/>
+                <a:cs typeface="Calibri" pitchFamily="34" charset="-120"/>
+              </a:rPr>
+              <a:t>arXiv · 2503.19461  ·  2025</a:t>
+            </a:r>
+            <a:endParaRPr lang="en-US" sz="1000" dirty="0"/>
+          </a:p>
+        </p:txBody>
+      </p:sp>
+      <p:sp>
+        <p:nvSpPr>
+          <p:cNvPr id="7" name="Text 5"/>
+          <p:cNvSpPr/>
+          <p:nvPr/>
+        </p:nvSpPr>
+        <p:spPr>
+          <a:xfrm>
+            <a:off x="411480" y="1600200"/>
+            <a:ext cx="5029200" cy="237744"/>
+          </a:xfrm>
+          <a:prstGeom prst="rect">
+            <a:avLst/>
+          </a:prstGeom>
+          <a:noFill/>
+          <a:ln/>
+        </p:spPr>
+        <p:txBody>
+          <a:bodyPr wrap="square" lIns="0" tIns="0" rIns="0" bIns="0" rtlCol="0" anchor="ctr"/>
+          <a:lstStyle/>
+          <a:p>
+            <a:pPr indent="0" marL="0">
+              <a:buNone/>
+            </a:pPr>
+            <a:r>
+              <a:rPr lang="en-US" sz="1100" dirty="0">
+                <a:solidFill>
+                  <a:srgbClr val="94A3B8"/>
+                </a:solidFill>
+                <a:latin typeface="Calibri" pitchFamily="34" charset="0"/>
+                <a:ea typeface="Calibri" pitchFamily="34" charset="-122"/>
+                <a:cs typeface="Calibri" pitchFamily="34" charset="-120"/>
+              </a:rPr>
+              <a:t>Sakana AI  ·  Google DeepMind  ·  University of British Columbia</a:t>
+            </a:r>
+            <a:endParaRPr lang="en-US" sz="1100" dirty="0"/>
+          </a:p>
+        </p:txBody>
+      </p:sp>
+      <p:sp>
+        <p:nvSpPr>
+          <p:cNvPr id="8" name="Shape 6"/>
+          <p:cNvSpPr/>
+          <p:nvPr/>
+        </p:nvSpPr>
+        <p:spPr>
+          <a:xfrm>
+            <a:off x="411480" y="1920240"/>
+            <a:ext cx="5029200" cy="13716"/>
+          </a:xfrm>
+          <a:prstGeom prst="rect">
+            <a:avLst/>
+          </a:prstGeom>
+          <a:solidFill>
+            <a:srgbClr val="475569"/>
+          </a:solidFill>
+          <a:ln/>
+        </p:spPr>
+      </p:sp>
+      <p:sp>
+        <p:nvSpPr>
+          <p:cNvPr id="9" name="Text 7"/>
+          <p:cNvSpPr/>
+          <p:nvPr/>
+        </p:nvSpPr>
+        <p:spPr>
+          <a:xfrm>
+            <a:off x="411480" y="2011680"/>
+            <a:ext cx="1828800" cy="201168"/>
+          </a:xfrm>
+          <a:prstGeom prst="rect">
+            <a:avLst/>
+          </a:prstGeom>
+          <a:noFill/>
+          <a:ln/>
+        </p:spPr>
+        <p:txBody>
+          <a:bodyPr wrap="square" lIns="0" tIns="0" rIns="0" bIns="0" rtlCol="0" anchor="ctr"/>
+          <a:lstStyle/>
+          <a:p>
+            <a:pPr indent="0" marL="0">
+              <a:buNone/>
+            </a:pPr>
+            <a:r>
+              <a:rPr lang="en-US" sz="800" b="1" spc="300" kern="0" dirty="0">
+                <a:solidFill>
+                  <a:srgbClr val="818CF8"/>
+                </a:solidFill>
+                <a:latin typeface="Calibri" pitchFamily="34" charset="0"/>
+                <a:ea typeface="Calibri" pitchFamily="34" charset="-122"/>
+                <a:cs typeface="Calibri" pitchFamily="34" charset="-120"/>
+              </a:rPr>
+              <a:t>CORE IDEA</a:t>
+            </a:r>
+            <a:endParaRPr lang="en-US" sz="800" dirty="0"/>
+          </a:p>
+        </p:txBody>
+      </p:sp>
+      <p:sp>
+        <p:nvSpPr>
+          <p:cNvPr id="10" name="Text 8"/>
+          <p:cNvSpPr/>
+          <p:nvPr/>
+        </p:nvSpPr>
+        <p:spPr>
+          <a:xfrm>
+            <a:off x="411480" y="2249424"/>
+            <a:ext cx="5029200" cy="658368"/>
+          </a:xfrm>
+          <a:prstGeom prst="rect">
+            <a:avLst/>
+          </a:prstGeom>
+          <a:noFill/>
+          <a:ln/>
+        </p:spPr>
+        <p:txBody>
+          <a:bodyPr wrap="square" lIns="0" tIns="0" rIns="0" bIns="0" rtlCol="0" anchor="ctr"/>
+          <a:lstStyle/>
+          <a:p>
+            <a:pPr indent="0" marL="0">
+              <a:buNone/>
+            </a:pPr>
+            <a:r>
+              <a:rPr lang="en-US" sz="1200" dirty="0">
+                <a:solidFill>
+                  <a:srgbClr val="E2E8F0"/>
+                </a:solidFill>
+                <a:latin typeface="Calibri" pitchFamily="34" charset="0"/>
+                <a:ea typeface="Calibri" pitchFamily="34" charset="-122"/>
+                <a:cs typeface="Calibri" pitchFamily="34" charset="-120"/>
+              </a:rPr>
+              <a:t>An agent that iteratively rewrites its own code to improve performance — validated by an empirical eval gate before each new version is deployed. The meta-agent proposes a diff; the eval gate either approves or blocks it.</a:t>
+            </a:r>
+            <a:endParaRPr lang="en-US" sz="1200" dirty="0"/>
+          </a:p>
+        </p:txBody>
+      </p:sp>
+      <p:sp>
+        <p:nvSpPr>
+          <p:cNvPr id="11" name="Text 9"/>
+          <p:cNvSpPr/>
+          <p:nvPr/>
+        </p:nvSpPr>
+        <p:spPr>
+          <a:xfrm>
+            <a:off x="411480" y="2999232"/>
+            <a:ext cx="3200400" cy="201168"/>
+          </a:xfrm>
+          <a:prstGeom prst="rect">
+            <a:avLst/>
+          </a:prstGeom>
+          <a:noFill/>
+          <a:ln/>
+        </p:spPr>
+        <p:txBody>
+          <a:bodyPr wrap="square" lIns="0" tIns="0" rIns="0" bIns="0" rtlCol="0" anchor="ctr"/>
+          <a:lstStyle/>
+          <a:p>
+            <a:pPr indent="0" marL="0">
+              <a:buNone/>
+            </a:pPr>
+            <a:r>
+              <a:rPr lang="en-US" sz="800" b="1" spc="300" kern="0" dirty="0">
+                <a:solidFill>
+                  <a:srgbClr val="38BDF8"/>
+                </a:solidFill>
+                <a:latin typeface="Calibri" pitchFamily="34" charset="0"/>
+                <a:ea typeface="Calibri" pitchFamily="34" charset="-122"/>
+                <a:cs typeface="Calibri" pitchFamily="34" charset="-120"/>
+              </a:rPr>
+              <a:t>HOW INFRABRAIN MAPS TO IT</a:t>
+            </a:r>
+            <a:endParaRPr lang="en-US" sz="800" dirty="0"/>
+          </a:p>
+        </p:txBody>
+      </p:sp>
+      <p:sp>
+        <p:nvSpPr>
+          <p:cNvPr id="12" name="Shape 10"/>
+          <p:cNvSpPr/>
+          <p:nvPr/>
+        </p:nvSpPr>
+        <p:spPr>
+          <a:xfrm>
+            <a:off x="411480" y="3246120"/>
+            <a:ext cx="1645920" cy="274320"/>
+          </a:xfrm>
+          <a:prstGeom prst="rect">
+            <a:avLst/>
+          </a:prstGeom>
+          <a:solidFill>
+            <a:srgbClr val="131D30"/>
+          </a:solidFill>
+          <a:ln/>
+        </p:spPr>
+      </p:sp>
+      <p:sp>
+        <p:nvSpPr>
+          <p:cNvPr id="13" name="Text 11"/>
+          <p:cNvSpPr/>
+          <p:nvPr/>
+        </p:nvSpPr>
+        <p:spPr>
+          <a:xfrm>
+            <a:off x="411480" y="3246120"/>
+            <a:ext cx="1645920" cy="274320"/>
+          </a:xfrm>
+          <a:prstGeom prst="rect">
+            <a:avLst/>
+          </a:prstGeom>
+          <a:noFill/>
+          <a:ln/>
+        </p:spPr>
+        <p:txBody>
+          <a:bodyPr wrap="square" lIns="0" tIns="0" rIns="0" bIns="0" rtlCol="0" anchor="ctr"/>
+          <a:lstStyle/>
+          <a:p>
+            <a:pPr algn="ctr" indent="0" marL="0">
+              <a:buNone/>
+            </a:pPr>
+            <a:r>
+              <a:rPr lang="en-US" sz="1000" dirty="0">
+                <a:solidFill>
+                  <a:srgbClr val="818CF8"/>
+                </a:solidFill>
+                <a:latin typeface="Calibri" pitchFamily="34" charset="0"/>
+                <a:ea typeface="Calibri" pitchFamily="34" charset="-122"/>
+                <a:cs typeface="Calibri" pitchFamily="34" charset="-120"/>
+              </a:rPr>
+              <a:t>Meta-agent</a:t>
+            </a:r>
+            <a:endParaRPr lang="en-US" sz="1000" dirty="0"/>
+          </a:p>
+        </p:txBody>
+      </p:sp>
+      <p:sp>
+        <p:nvSpPr>
+          <p:cNvPr id="14" name="Text 12"/>
+          <p:cNvSpPr/>
+          <p:nvPr/>
+        </p:nvSpPr>
+        <p:spPr>
+          <a:xfrm>
+            <a:off x="2103120" y="3246120"/>
+            <a:ext cx="274320" cy="274320"/>
+          </a:xfrm>
+          <a:prstGeom prst="rect">
+            <a:avLst/>
+          </a:prstGeom>
+          <a:noFill/>
+          <a:ln/>
+        </p:spPr>
+        <p:txBody>
+          <a:bodyPr wrap="square" lIns="0" tIns="0" rIns="0" bIns="0" rtlCol="0" anchor="ctr"/>
+          <a:lstStyle/>
+          <a:p>
+            <a:pPr algn="ctr" indent="0" marL="0">
+              <a:buNone/>
+            </a:pPr>
+            <a:r>
+              <a:rPr lang="en-US" sz="1200" b="1" dirty="0">
+                <a:solidFill>
+                  <a:srgbClr val="475569"/>
+                </a:solidFill>
+                <a:latin typeface="Calibri" pitchFamily="34" charset="0"/>
+                <a:ea typeface="Calibri" pitchFamily="34" charset="-122"/>
+                <a:cs typeface="Calibri" pitchFamily="34" charset="-120"/>
+              </a:rPr>
+              <a:t>→</a:t>
+            </a:r>
+            <a:endParaRPr lang="en-US" sz="1200" dirty="0"/>
+          </a:p>
+        </p:txBody>
+      </p:sp>
+      <p:sp>
+        <p:nvSpPr>
+          <p:cNvPr id="15" name="Text 13"/>
+          <p:cNvSpPr/>
+          <p:nvPr/>
+        </p:nvSpPr>
+        <p:spPr>
+          <a:xfrm>
+            <a:off x="2423160" y="3246120"/>
+            <a:ext cx="3017520" cy="274320"/>
+          </a:xfrm>
+          <a:prstGeom prst="rect">
+            <a:avLst/>
+          </a:prstGeom>
+          <a:noFill/>
+          <a:ln/>
+        </p:spPr>
+        <p:txBody>
+          <a:bodyPr wrap="square" lIns="0" tIns="0" rIns="0" bIns="0" rtlCol="0" anchor="ctr"/>
+          <a:lstStyle/>
+          <a:p>
+            <a:pPr indent="0" marL="0">
+              <a:buNone/>
+            </a:pPr>
+            <a:r>
+              <a:rPr lang="en-US" sz="1000" dirty="0">
+                <a:solidFill>
+                  <a:srgbClr val="38BDF8"/>
+                </a:solidFill>
+                <a:latin typeface="Calibri" pitchFamily="34" charset="0"/>
+                <a:ea typeface="Calibri" pitchFamily="34" charset="-122"/>
+                <a:cs typeface="Calibri" pitchFamily="34" charset="-120"/>
+              </a:rPr>
+              <a:t>POST /api/meta   (InfraBrain backend)</a:t>
+            </a:r>
+            <a:endParaRPr lang="en-US" sz="1000" dirty="0"/>
+          </a:p>
+        </p:txBody>
+      </p:sp>
+      <p:sp>
+        <p:nvSpPr>
+          <p:cNvPr id="16" name="Shape 14"/>
+          <p:cNvSpPr/>
+          <p:nvPr/>
+        </p:nvSpPr>
+        <p:spPr>
+          <a:xfrm>
+            <a:off x="411480" y="3593592"/>
+            <a:ext cx="1645920" cy="274320"/>
+          </a:xfrm>
+          <a:prstGeom prst="rect">
+            <a:avLst/>
+          </a:prstGeom>
+          <a:solidFill>
+            <a:srgbClr val="131D30"/>
+          </a:solidFill>
+          <a:ln/>
+        </p:spPr>
+      </p:sp>
+      <p:sp>
+        <p:nvSpPr>
+          <p:cNvPr id="17" name="Text 15"/>
+          <p:cNvSpPr/>
+          <p:nvPr/>
+        </p:nvSpPr>
+        <p:spPr>
+          <a:xfrm>
+            <a:off x="411480" y="3593592"/>
+            <a:ext cx="1645920" cy="274320"/>
+          </a:xfrm>
+          <a:prstGeom prst="rect">
+            <a:avLst/>
+          </a:prstGeom>
+          <a:noFill/>
+          <a:ln/>
+        </p:spPr>
+        <p:txBody>
+          <a:bodyPr wrap="square" lIns="0" tIns="0" rIns="0" bIns="0" rtlCol="0" anchor="ctr"/>
+          <a:lstStyle/>
+          <a:p>
+            <a:pPr algn="ctr" indent="0" marL="0">
+              <a:buNone/>
+            </a:pPr>
+            <a:r>
+              <a:rPr lang="en-US" sz="1000" dirty="0">
+                <a:solidFill>
+                  <a:srgbClr val="818CF8"/>
+                </a:solidFill>
+                <a:latin typeface="Calibri" pitchFamily="34" charset="0"/>
+                <a:ea typeface="Calibri" pitchFamily="34" charset="-122"/>
+                <a:cs typeface="Calibri" pitchFamily="34" charset="-120"/>
+              </a:rPr>
+              <a:t>Code diff / rewrite</a:t>
+            </a:r>
+            <a:endParaRPr lang="en-US" sz="1000" dirty="0"/>
+          </a:p>
+        </p:txBody>
+      </p:sp>
+      <p:sp>
+        <p:nvSpPr>
+          <p:cNvPr id="18" name="Text 16"/>
+          <p:cNvSpPr/>
+          <p:nvPr/>
+        </p:nvSpPr>
+        <p:spPr>
+          <a:xfrm>
+            <a:off x="2103120" y="3593592"/>
+            <a:ext cx="274320" cy="274320"/>
+          </a:xfrm>
+          <a:prstGeom prst="rect">
+            <a:avLst/>
+          </a:prstGeom>
+          <a:noFill/>
+          <a:ln/>
+        </p:spPr>
+        <p:txBody>
+          <a:bodyPr wrap="square" lIns="0" tIns="0" rIns="0" bIns="0" rtlCol="0" anchor="ctr"/>
+          <a:lstStyle/>
+          <a:p>
+            <a:pPr algn="ctr" indent="0" marL="0">
+              <a:buNone/>
+            </a:pPr>
+            <a:r>
+              <a:rPr lang="en-US" sz="1200" b="1" dirty="0">
+                <a:solidFill>
+                  <a:srgbClr val="475569"/>
+                </a:solidFill>
+                <a:latin typeface="Calibri" pitchFamily="34" charset="0"/>
+                <a:ea typeface="Calibri" pitchFamily="34" charset="-122"/>
+                <a:cs typeface="Calibri" pitchFamily="34" charset="-120"/>
+              </a:rPr>
+              <a:t>→</a:t>
+            </a:r>
+            <a:endParaRPr lang="en-US" sz="1200" dirty="0"/>
+          </a:p>
+        </p:txBody>
+      </p:sp>
+      <p:sp>
+        <p:nvSpPr>
+          <p:cNvPr id="19" name="Text 17"/>
+          <p:cNvSpPr/>
+          <p:nvPr/>
+        </p:nvSpPr>
+        <p:spPr>
+          <a:xfrm>
+            <a:off x="2423160" y="3593592"/>
+            <a:ext cx="3017520" cy="274320"/>
+          </a:xfrm>
+          <a:prstGeom prst="rect">
+            <a:avLst/>
+          </a:prstGeom>
+          <a:noFill/>
+          <a:ln/>
+        </p:spPr>
+        <p:txBody>
+          <a:bodyPr wrap="square" lIns="0" tIns="0" rIns="0" bIns="0" rtlCol="0" anchor="ctr"/>
+          <a:lstStyle/>
+          <a:p>
+            <a:pPr indent="0" marL="0">
+              <a:buNone/>
+            </a:pPr>
+            <a:r>
+              <a:rPr lang="en-US" sz="1000" dirty="0">
+                <a:solidFill>
+                  <a:srgbClr val="38BDF8"/>
+                </a:solidFill>
+                <a:latin typeface="Calibri" pitchFamily="34" charset="0"/>
+                <a:ea typeface="Calibri" pitchFamily="34" charset="-122"/>
+                <a:cs typeface="Calibri" pitchFamily="34" charset="-120"/>
+              </a:rPr>
+              <a:t>Task-agent prompt rewrite from KG patterns</a:t>
+            </a:r>
+            <a:endParaRPr lang="en-US" sz="1000" dirty="0"/>
+          </a:p>
+        </p:txBody>
+      </p:sp>
+      <p:sp>
+        <p:nvSpPr>
+          <p:cNvPr id="20" name="Shape 18"/>
+          <p:cNvSpPr/>
+          <p:nvPr/>
+        </p:nvSpPr>
+        <p:spPr>
+          <a:xfrm>
+            <a:off x="411480" y="3941064"/>
+            <a:ext cx="1645920" cy="274320"/>
+          </a:xfrm>
+          <a:prstGeom prst="rect">
+            <a:avLst/>
+          </a:prstGeom>
+          <a:solidFill>
+            <a:srgbClr val="131D30"/>
+          </a:solidFill>
+          <a:ln/>
+        </p:spPr>
+      </p:sp>
+      <p:sp>
+        <p:nvSpPr>
+          <p:cNvPr id="21" name="Text 19"/>
+          <p:cNvSpPr/>
+          <p:nvPr/>
+        </p:nvSpPr>
+        <p:spPr>
+          <a:xfrm>
+            <a:off x="411480" y="3941064"/>
+            <a:ext cx="1645920" cy="274320"/>
+          </a:xfrm>
+          <a:prstGeom prst="rect">
+            <a:avLst/>
+          </a:prstGeom>
+          <a:noFill/>
+          <a:ln/>
+        </p:spPr>
+        <p:txBody>
+          <a:bodyPr wrap="square" lIns="0" tIns="0" rIns="0" bIns="0" rtlCol="0" anchor="ctr"/>
+          <a:lstStyle/>
+          <a:p>
+            <a:pPr algn="ctr" indent="0" marL="0">
+              <a:buNone/>
+            </a:pPr>
+            <a:r>
+              <a:rPr lang="en-US" sz="1000" dirty="0">
+                <a:solidFill>
+                  <a:srgbClr val="818CF8"/>
+                </a:solidFill>
+                <a:latin typeface="Calibri" pitchFamily="34" charset="0"/>
+                <a:ea typeface="Calibri" pitchFamily="34" charset="-122"/>
+                <a:cs typeface="Calibri" pitchFamily="34" charset="-120"/>
+              </a:rPr>
+              <a:t>Eval gate</a:t>
+            </a:r>
+            <a:endParaRPr lang="en-US" sz="1000" dirty="0"/>
+          </a:p>
+        </p:txBody>
+      </p:sp>
+      <p:sp>
+        <p:nvSpPr>
+          <p:cNvPr id="22" name="Text 20"/>
+          <p:cNvSpPr/>
+          <p:nvPr/>
+        </p:nvSpPr>
+        <p:spPr>
+          <a:xfrm>
+            <a:off x="2103120" y="3941064"/>
+            <a:ext cx="274320" cy="274320"/>
+          </a:xfrm>
+          <a:prstGeom prst="rect">
+            <a:avLst/>
+          </a:prstGeom>
+          <a:noFill/>
+          <a:ln/>
+        </p:spPr>
+        <p:txBody>
+          <a:bodyPr wrap="square" lIns="0" tIns="0" rIns="0" bIns="0" rtlCol="0" anchor="ctr"/>
+          <a:lstStyle/>
+          <a:p>
+            <a:pPr algn="ctr" indent="0" marL="0">
+              <a:buNone/>
+            </a:pPr>
+            <a:r>
+              <a:rPr lang="en-US" sz="1200" b="1" dirty="0">
+                <a:solidFill>
+                  <a:srgbClr val="475569"/>
+                </a:solidFill>
+                <a:latin typeface="Calibri" pitchFamily="34" charset="0"/>
+                <a:ea typeface="Calibri" pitchFamily="34" charset="-122"/>
+                <a:cs typeface="Calibri" pitchFamily="34" charset="-120"/>
+              </a:rPr>
+              <a:t>→</a:t>
+            </a:r>
+            <a:endParaRPr lang="en-US" sz="1200" dirty="0"/>
+          </a:p>
+        </p:txBody>
+      </p:sp>
+      <p:sp>
+        <p:nvSpPr>
+          <p:cNvPr id="23" name="Text 21"/>
+          <p:cNvSpPr/>
+          <p:nvPr/>
+        </p:nvSpPr>
+        <p:spPr>
+          <a:xfrm>
+            <a:off x="2423160" y="3941064"/>
+            <a:ext cx="3017520" cy="274320"/>
+          </a:xfrm>
+          <a:prstGeom prst="rect">
+            <a:avLst/>
+          </a:prstGeom>
+          <a:noFill/>
+          <a:ln/>
+        </p:spPr>
+        <p:txBody>
+          <a:bodyPr wrap="square" lIns="0" tIns="0" rIns="0" bIns="0" rtlCol="0" anchor="ctr"/>
+          <a:lstStyle/>
+          <a:p>
+            <a:pPr indent="0" marL="0">
+              <a:buNone/>
+            </a:pPr>
+            <a:r>
+              <a:rPr lang="en-US" sz="1000" dirty="0">
+                <a:solidFill>
+                  <a:srgbClr val="38BDF8"/>
+                </a:solidFill>
+                <a:latin typeface="Calibri" pitchFamily="34" charset="0"/>
+                <a:ea typeface="Calibri" pitchFamily="34" charset="-122"/>
+                <a:cs typeface="Calibri" pitchFamily="34" charset="-120"/>
+              </a:rPr>
+              <a:t>infrabrain-eval   (120 live Gemini API calls)</a:t>
+            </a:r>
+            <a:endParaRPr lang="en-US" sz="1000" dirty="0"/>
+          </a:p>
+        </p:txBody>
+      </p:sp>
+      <p:sp>
+        <p:nvSpPr>
+          <p:cNvPr id="24" name="Shape 22"/>
+          <p:cNvSpPr/>
+          <p:nvPr/>
+        </p:nvSpPr>
+        <p:spPr>
+          <a:xfrm>
+            <a:off x="411480" y="4288536"/>
+            <a:ext cx="1645920" cy="274320"/>
+          </a:xfrm>
+          <a:prstGeom prst="rect">
+            <a:avLst/>
+          </a:prstGeom>
+          <a:solidFill>
+            <a:srgbClr val="131D30"/>
+          </a:solidFill>
+          <a:ln/>
+        </p:spPr>
+      </p:sp>
+      <p:sp>
+        <p:nvSpPr>
+          <p:cNvPr id="25" name="Text 23"/>
+          <p:cNvSpPr/>
+          <p:nvPr/>
+        </p:nvSpPr>
+        <p:spPr>
+          <a:xfrm>
+            <a:off x="411480" y="4288536"/>
+            <a:ext cx="1645920" cy="274320"/>
+          </a:xfrm>
+          <a:prstGeom prst="rect">
+            <a:avLst/>
+          </a:prstGeom>
+          <a:noFill/>
+          <a:ln/>
+        </p:spPr>
+        <p:txBody>
+          <a:bodyPr wrap="square" lIns="0" tIns="0" rIns="0" bIns="0" rtlCol="0" anchor="ctr"/>
+          <a:lstStyle/>
+          <a:p>
+            <a:pPr algn="ctr" indent="0" marL="0">
+              <a:buNone/>
+            </a:pPr>
+            <a:r>
+              <a:rPr lang="en-US" sz="1000" dirty="0">
+                <a:solidFill>
+                  <a:srgbClr val="818CF8"/>
+                </a:solidFill>
+                <a:latin typeface="Calibri" pitchFamily="34" charset="0"/>
+                <a:ea typeface="Calibri" pitchFamily="34" charset="-122"/>
+                <a:cs typeface="Calibri" pitchFamily="34" charset="-120"/>
+              </a:rPr>
+              <a:t>Block regression</a:t>
+            </a:r>
+            <a:endParaRPr lang="en-US" sz="1000" dirty="0"/>
+          </a:p>
+        </p:txBody>
+      </p:sp>
+      <p:sp>
+        <p:nvSpPr>
+          <p:cNvPr id="26" name="Text 24"/>
+          <p:cNvSpPr/>
+          <p:nvPr/>
+        </p:nvSpPr>
+        <p:spPr>
+          <a:xfrm>
+            <a:off x="2103120" y="4288536"/>
+            <a:ext cx="274320" cy="274320"/>
+          </a:xfrm>
+          <a:prstGeom prst="rect">
+            <a:avLst/>
+          </a:prstGeom>
+          <a:noFill/>
+          <a:ln/>
+        </p:spPr>
+        <p:txBody>
+          <a:bodyPr wrap="square" lIns="0" tIns="0" rIns="0" bIns="0" rtlCol="0" anchor="ctr"/>
+          <a:lstStyle/>
+          <a:p>
+            <a:pPr algn="ctr" indent="0" marL="0">
+              <a:buNone/>
+            </a:pPr>
+            <a:r>
+              <a:rPr lang="en-US" sz="1200" b="1" dirty="0">
+                <a:solidFill>
+                  <a:srgbClr val="475569"/>
+                </a:solidFill>
+                <a:latin typeface="Calibri" pitchFamily="34" charset="0"/>
+                <a:ea typeface="Calibri" pitchFamily="34" charset="-122"/>
+                <a:cs typeface="Calibri" pitchFamily="34" charset="-120"/>
+              </a:rPr>
+              <a:t>→</a:t>
+            </a:r>
+            <a:endParaRPr lang="en-US" sz="1200" dirty="0"/>
+          </a:p>
+        </p:txBody>
+      </p:sp>
+      <p:sp>
+        <p:nvSpPr>
+          <p:cNvPr id="27" name="Text 25"/>
+          <p:cNvSpPr/>
+          <p:nvPr/>
+        </p:nvSpPr>
+        <p:spPr>
+          <a:xfrm>
+            <a:off x="2423160" y="4288536"/>
+            <a:ext cx="3017520" cy="274320"/>
+          </a:xfrm>
+          <a:prstGeom prst="rect">
+            <a:avLst/>
+          </a:prstGeom>
+          <a:noFill/>
+          <a:ln/>
+        </p:spPr>
+        <p:txBody>
+          <a:bodyPr wrap="square" lIns="0" tIns="0" rIns="0" bIns="0" rtlCol="0" anchor="ctr"/>
+          <a:lstStyle/>
+          <a:p>
+            <a:pPr indent="0" marL="0">
+              <a:buNone/>
+            </a:pPr>
+            <a:r>
+              <a:rPr lang="en-US" sz="1000" dirty="0">
+                <a:solidFill>
+                  <a:srgbClr val="38BDF8"/>
+                </a:solidFill>
+                <a:latin typeface="Calibri" pitchFamily="34" charset="0"/>
+                <a:ea typeface="Calibri" pitchFamily="34" charset="-122"/>
+                <a:cs typeface="Calibri" pitchFamily="34" charset="-120"/>
+              </a:rPr>
+              <a:t>Gen-5 CRITICAL NOTE caught before deploy</a:t>
+            </a:r>
+            <a:endParaRPr lang="en-US" sz="1000" dirty="0"/>
+          </a:p>
+        </p:txBody>
+      </p:sp>
+      <p:sp>
+        <p:nvSpPr>
+          <p:cNvPr id="28" name="Shape 26"/>
+          <p:cNvSpPr/>
+          <p:nvPr/>
+        </p:nvSpPr>
+        <p:spPr>
+          <a:xfrm>
+            <a:off x="5715000" y="548640"/>
+            <a:ext cx="3017520" cy="3931920"/>
+          </a:xfrm>
+          <a:prstGeom prst="rect">
+            <a:avLst/>
+          </a:prstGeom>
+          <a:solidFill>
+            <a:srgbClr val="131D30"/>
+          </a:solidFill>
+          <a:ln w="12700">
+            <a:solidFill>
+              <a:srgbClr val="475569"/>
+            </a:solidFill>
+            <a:prstDash val="dash"/>
+          </a:ln>
+        </p:spPr>
+      </p:sp>
+      <p:sp>
+        <p:nvSpPr>
+          <p:cNvPr id="29" name="Text 27"/>
+          <p:cNvSpPr/>
+          <p:nvPr/>
+        </p:nvSpPr>
+        <p:spPr>
+          <a:xfrm>
+            <a:off x="5715000" y="2011680"/>
+            <a:ext cx="3017520" cy="914400"/>
+          </a:xfrm>
+          <a:prstGeom prst="rect">
+            <a:avLst/>
+          </a:prstGeom>
+          <a:noFill/>
+          <a:ln/>
+        </p:spPr>
+        <p:txBody>
+          <a:bodyPr wrap="square" lIns="0" tIns="0" rIns="0" bIns="0" rtlCol="0" anchor="ctr"/>
+          <a:lstStyle/>
+          <a:p>
+            <a:pPr algn="ctr" indent="0" marL="0">
+              <a:buNone/>
+            </a:pPr>
+            <a:r>
+              <a:rPr lang="en-US" sz="1300" dirty="0">
+                <a:solidFill>
+                  <a:srgbClr val="475569"/>
+                </a:solidFill>
+                <a:latin typeface="Calibri" pitchFamily="34" charset="0"/>
+                <a:ea typeface="Calibri" pitchFamily="34" charset="-122"/>
+                <a:cs typeface="Calibri" pitchFamily="34" charset="-120"/>
+              </a:rPr>
+              <a:t>[ Paper cover image</a:t>
+            </a:r>
+            <a:endParaRPr lang="en-US" sz="1300" dirty="0"/>
+          </a:p>
+          <a:p>
+            <a:pPr algn="ctr" indent="0" marL="0">
+              <a:buNone/>
+            </a:pPr>
+            <a:r>
+              <a:rPr lang="en-US" sz="1300" dirty="0">
+                <a:solidFill>
+                  <a:srgbClr val="475569"/>
+                </a:solidFill>
+                <a:latin typeface="Calibri" pitchFamily="34" charset="0"/>
+                <a:ea typeface="Calibri" pitchFamily="34" charset="-122"/>
+                <a:cs typeface="Calibri" pitchFamily="34" charset="-120"/>
+              </a:rPr>
+              <a:t>  — add here ]</a:t>
+            </a:r>
+            <a:endParaRPr lang="en-US" sz="1300" dirty="0"/>
+          </a:p>
+        </p:txBody>
+      </p:sp>
+      <p:sp>
+        <p:nvSpPr>
+          <p:cNvPr id="30" name="Shape 28"/>
+          <p:cNvSpPr/>
+          <p:nvPr/>
+        </p:nvSpPr>
+        <p:spPr>
+          <a:xfrm>
+            <a:off x="5715000" y="548640"/>
+            <a:ext cx="3017520" cy="54864"/>
+          </a:xfrm>
+          <a:prstGeom prst="rect">
+            <a:avLst/>
+          </a:prstGeom>
+          <a:solidFill>
+            <a:srgbClr val="818CF8"/>
+          </a:solidFill>
+          <a:ln/>
+        </p:spPr>
+      </p:sp>
+      <p:sp>
+        <p:nvSpPr>
+          <p:cNvPr id="31" name="Text 29"/>
+          <p:cNvSpPr/>
+          <p:nvPr/>
+        </p:nvSpPr>
+        <p:spPr>
+          <a:xfrm>
+            <a:off x="411480" y="4864608"/>
+            <a:ext cx="8321040" cy="164592"/>
+          </a:xfrm>
+          <a:prstGeom prst="rect">
+            <a:avLst/>
+          </a:prstGeom>
+          <a:noFill/>
+          <a:ln/>
+        </p:spPr>
+        <p:txBody>
+          <a:bodyPr wrap="square" lIns="0" tIns="0" rIns="0" bIns="0" rtlCol="0" anchor="ctr"/>
+          <a:lstStyle/>
+          <a:p>
+            <a:pPr indent="0" marL="0">
+              <a:buNone/>
+            </a:pPr>
+            <a:r>
+              <a:rPr lang="en-US" sz="900" dirty="0">
+                <a:solidFill>
+                  <a:srgbClr val="475569"/>
+                </a:solidFill>
+                <a:latin typeface="Calibri" pitchFamily="34" charset="0"/>
+                <a:ea typeface="Calibri" pitchFamily="34" charset="-122"/>
+                <a:cs typeface="Calibri" pitchFamily="34" charset="-120"/>
+              </a:rPr>
+              <a:t>arxiv.org/abs/2503.19461</a:t>
+            </a:r>
+            <a:endParaRPr lang="en-US" sz="900" dirty="0"/>
+          </a:p>
+        </p:txBody>
+      </p:sp>
+    </p:spTree>
+  </p:cSld>
+  <p:clrMapOvr>
+    <a:masterClrMapping/>
+  </p:clrMapOvr>
+</p:sld>
+</file>
+
+<file path=ppt/slides/slide6.xml><?xml version="1.0" encoding="utf-8"?>
+<p:sld xmlns:a="http://schemas.openxmlformats.org/drawingml/2006/main" xmlns:r="http://schemas.openxmlformats.org/officeDocument/2006/relationships" xmlns:p="http://schemas.openxmlformats.org/presentationml/2006/main">
+  <p:cSld name="Slide 6">
+    <p:spTree>
+      <p:nvGrpSpPr>
+        <p:cNvPr id="1" name=""/>
+        <p:cNvGrpSpPr/>
+        <p:nvPr/>
+      </p:nvGrpSpPr>
+      <p:grpSpPr>
+        <a:xfrm>
+          <a:off x="0" y="0"/>
+          <a:ext cx="0" cy="0"/>
+          <a:chOff x="0" y="0"/>
+          <a:chExt cx="0" cy="0"/>
+        </a:xfrm>
+      </p:grpSpPr>
+      <p:sp>
+        <p:nvSpPr>
+          <p:cNvPr id="2" name="Shape 0"/>
+          <p:cNvSpPr/>
+          <p:nvPr/>
+        </p:nvSpPr>
+        <p:spPr>
+          <a:xfrm>
+            <a:off x="0" y="0"/>
+            <a:ext cx="9144000" cy="5143500"/>
+          </a:xfrm>
+          <a:prstGeom prst="rect">
+            <a:avLst/>
+          </a:prstGeom>
+          <a:solidFill>
+            <a:srgbClr val="0A0F1E"/>
+          </a:solidFill>
+          <a:ln/>
+        </p:spPr>
+      </p:sp>
+      <p:sp>
+        <p:nvSpPr>
+          <p:cNvPr id="3" name="Text 1"/>
+          <p:cNvSpPr/>
+          <p:nvPr/>
+        </p:nvSpPr>
+        <p:spPr>
+          <a:xfrm>
+            <a:off x="411480" y="274320"/>
+            <a:ext cx="2743200" cy="201168"/>
+          </a:xfrm>
+          <a:prstGeom prst="rect">
+            <a:avLst/>
+          </a:prstGeom>
+          <a:noFill/>
+          <a:ln/>
+        </p:spPr>
+        <p:txBody>
+          <a:bodyPr wrap="square" rtlCol="0" anchor="ctr"/>
+          <a:lstStyle/>
+          <a:p>
+            <a:pPr indent="0" marL="0">
+              <a:buNone/>
+            </a:pPr>
+            <a:r>
+              <a:rPr lang="en-US" sz="900" b="1" spc="400" kern="0" dirty="0">
+                <a:solidFill>
+                  <a:srgbClr val="38BDF8"/>
+                </a:solidFill>
+                <a:latin typeface="Calibri" pitchFamily="34" charset="0"/>
+                <a:ea typeface="Calibri" pitchFamily="34" charset="-122"/>
+                <a:cs typeface="Calibri" pitchFamily="34" charset="-120"/>
+              </a:rPr>
               <a:t>PART 2  ·  REAL RESULTS — 120 GEMINI API CALLS</a:t>
             </a:r>
             <a:endParaRPr lang="en-US" sz="900" dirty="0"/>
@@ -6150,9 +7287,9 @@
 </p:sld>
 </file>
 
-<file path=ppt/slides/slide6.xml><?xml version="1.0" encoding="utf-8"?>
+<file path=ppt/slides/slide7.xml><?xml version="1.0" encoding="utf-8"?>
 <p:sld xmlns:a="http://schemas.openxmlformats.org/drawingml/2006/main" xmlns:r="http://schemas.openxmlformats.org/officeDocument/2006/relationships" xmlns:p="http://schemas.openxmlformats.org/presentationml/2006/main">
-  <p:cSld name="Slide 6">
+  <p:cSld name="Slide 7">
     <p:spTree>
       <p:nvGrpSpPr>
         <p:cNvPr id="1" name=""/>

</xml_diff>

<commit_message>
revert: restore PPTX to 6-slide version (paper slide is SLIDES.md only)
Co-Authored-By: Claude Sonnet 4.6 <noreply@anthropic.com>
</commit_message>
<xml_diff>
--- a/InfraBrain_Presentation.pptx
+++ b/InfraBrain_Presentation.pptx
@@ -11,10 +11,9 @@
     <p:sldId id="259" r:id="rId5"/>
     <p:sldId id="260" r:id="rId6"/>
     <p:sldId id="261" r:id="rId7"/>
-    <p:sldId id="262" r:id="rId8"/>
   </p:sldIdLst>
   <p:notesMasterIdLst>
-    <p:notesMasterId r:id="rId9"/>
+    <p:notesMasterId r:id="rId8"/>
   </p:notesMasterIdLst>
   <p:sldSz cx="9144000" cy="5143500"/>
   <p:notesSz cx="5143500" cy="9144000"/>
@@ -1398,94 +1397,6 @@
             <a:fld id="{F7021451-1387-4CA6-816F-3879F97B5CBC}" type="slidenum">
               <a:rPr lang="en-US"/>
               <a:t>6</a:t>
-            </a:fld>
-            <a:endParaRPr lang="en-US"/>
-          </a:p>
-        </p:txBody>
-      </p:sp>
-    </p:spTree>
-    <p:extLst>
-      <p:ext uri="{BB962C8B-B14F-4D97-AF65-F5344CB8AC3E}">
-        <p14:creationId xmlns:p14="http://schemas.microsoft.com/office/powerpoint/2010/main" val="1024086991"/>
-      </p:ext>
-    </p:extLst>
-  </p:cSld>
-  <p:clrMapOvr>
-    <a:masterClrMapping/>
-  </p:clrMapOvr>
-</p:notes>
-</file>
-
-<file path=ppt/notesSlides/notesSlide7.xml><?xml version="1.0" encoding="utf-8"?>
-<p:notes xmlns:a="http://schemas.openxmlformats.org/drawingml/2006/main" xmlns:r="http://schemas.openxmlformats.org/officeDocument/2006/relationships" xmlns:p="http://schemas.openxmlformats.org/presentationml/2006/main">
-  <p:cSld>
-    <p:spTree>
-      <p:nvGrpSpPr>
-        <p:cNvPr id="1" name=""/>
-        <p:cNvGrpSpPr/>
-        <p:nvPr/>
-      </p:nvGrpSpPr>
-      <p:grpSpPr>
-        <a:xfrm>
-          <a:off x="0" y="0"/>
-          <a:ext cx="0" cy="0"/>
-          <a:chOff x="0" y="0"/>
-          <a:chExt cx="0" cy="0"/>
-        </a:xfrm>
-      </p:grpSpPr>
-      <p:sp>
-        <p:nvSpPr>
-          <p:cNvPr id="2" name="Slide Image Placeholder 1"/>
-          <p:cNvSpPr>
-            <a:spLocks noGrp="1" noRot="1" noChangeAspect="1"/>
-          </p:cNvSpPr>
-          <p:nvPr>
-            <p:ph type="sldImg"/>
-          </p:nvPr>
-        </p:nvSpPr>
-        <p:spPr/>
-      </p:sp>
-      <p:sp>
-        <p:nvSpPr>
-          <p:cNvPr id="3" name="Notes Placeholder 2"/>
-          <p:cNvSpPr>
-            <a:spLocks noGrp="1"/>
-          </p:cNvSpPr>
-          <p:nvPr>
-            <p:ph type="body" idx="1"/>
-          </p:nvPr>
-        </p:nvSpPr>
-        <p:spPr/>
-        <p:txBody>
-          <a:bodyPr/>
-          <a:lstStyle/>
-          <a:p>
-            <a:r>
-              <a:rPr lang="en-US" dirty="0"/>
-              <a:t/>
-            </a:r>
-            <a:endParaRPr lang="en-US" dirty="0"/>
-          </a:p>
-        </p:txBody>
-      </p:sp>
-      <p:sp>
-        <p:nvSpPr>
-          <p:cNvPr id="4" name="Slide Number Placeholder 3"/>
-          <p:cNvSpPr>
-            <a:spLocks noGrp="1"/>
-          </p:cNvSpPr>
-          <p:nvPr>
-            <p:ph type="sldNum" sz="quarter" idx="10"/>
-          </p:nvPr>
-        </p:nvSpPr>
-        <p:spPr/>
-        <p:txBody>
-          <a:bodyPr/>
-          <a:lstStyle/>
-          <a:p>
-            <a:fld id="{F7021451-1387-4CA6-816F-3879F97B5CBC}" type="slidenum">
-              <a:rPr lang="en-US"/>
-              <a:t>7</a:t>
             </a:fld>
             <a:endParaRPr lang="en-US"/>
           </a:p>
@@ -2335,7 +2246,7 @@
                 <a:ea typeface="Calibri" pitchFamily="34" charset="-122"/>
                 <a:cs typeface="Calibri" pitchFamily="34" charset="-120"/>
               </a:rPr>
-              <a:t>A Self-Improving Agent That Learns from Every Override</a:t>
+              <a:t>A Self-Improving GPU Diagnostic Agent</a:t>
             </a:r>
             <a:endParaRPr lang="en-US" sz="2000" dirty="0"/>
           </a:p>
@@ -5665,7 +5576,7 @@
                 <a:ea typeface="Calibri" pitchFamily="34" charset="-122"/>
                 <a:cs typeface="Calibri" pitchFamily="34" charset="-120"/>
               </a:rPr>
-              <a:t>PART 2  ·  THE PAPER BEHIND IT</a:t>
+              <a:t>PART 2  ·  REAL RESULTS — 120 GEMINI API CALLS</a:t>
             </a:r>
             <a:endParaRPr lang="en-US" sz="900" dirty="0"/>
           </a:p>
@@ -5680,7 +5591,7 @@
         <p:spPr>
           <a:xfrm>
             <a:off x="411480" y="548640"/>
-            <a:ext cx="5120640" cy="685800"/>
+            <a:ext cx="8321040" cy="548640"/>
           </a:xfrm>
           <a:prstGeom prst="rect">
             <a:avLst/>
@@ -5696,7 +5607,7 @@
               <a:buNone/>
             </a:pPr>
             <a:r>
-              <a:rPr lang="en-US" sz="3600" b="1" dirty="0">
+              <a:rPr lang="en-US" sz="2600" b="1" dirty="0">
                 <a:solidFill>
                   <a:srgbClr val="FFFFFF"/>
                 </a:solidFill>
@@ -5704,832 +5615,65 @@
                 <a:ea typeface="Calibri" pitchFamily="34" charset="-122"/>
                 <a:cs typeface="Calibri" pitchFamily="34" charset="-120"/>
               </a:rPr>
-              <a:t>Darwin Gödel Machine</a:t>
-            </a:r>
-            <a:endParaRPr lang="en-US" sz="3600" dirty="0"/>
-          </a:p>
-        </p:txBody>
-      </p:sp>
-      <p:sp>
-        <p:nvSpPr>
-          <p:cNvPr id="5" name="Shape 3"/>
-          <p:cNvSpPr/>
-          <p:nvPr/>
-        </p:nvSpPr>
-        <p:spPr>
-          <a:xfrm>
-            <a:off x="411480" y="1261872"/>
-            <a:ext cx="2103120" cy="274320"/>
+              <a:t>KG corrections work. The eval gate catches what doesn't.</a:t>
+            </a:r>
+            <a:endParaRPr lang="en-US" sz="2600" dirty="0"/>
+          </a:p>
+        </p:txBody>
+      </p:sp>
+      <p:graphicFrame>
+        <p:nvGraphicFramePr>
+          <p:cNvPr id="5" name="Chart 0" descr=""/>
+          <p:cNvGraphicFramePr/>
+          <p:nvPr/>
+        </p:nvGraphicFramePr>
+        <p:xfrm>
+          <a:off x="320040" y="1188720"/>
+          <a:ext cx="5212080" cy="3200400"/>
+        </p:xfrm>
+        <a:graphic xmlns:a="http://schemas.openxmlformats.org/drawingml/2006/main">
+          <a:graphicData uri="http://schemas.openxmlformats.org/drawingml/2006/chart">
+            <c:chart xmlns:c="http://schemas.openxmlformats.org/drawingml/2006/chart" r:id="rId1"/>
+          </a:graphicData>
+        </a:graphic>
+      </p:graphicFrame>
+      <p:sp>
+        <p:nvSpPr>
+          <p:cNvPr id="6" name="Shape 3"/>
+          <p:cNvSpPr/>
+          <p:nvPr/>
+        </p:nvSpPr>
+        <p:spPr>
+          <a:xfrm>
+            <a:off x="1005840" y="1325880"/>
+            <a:ext cx="1554480" cy="402336"/>
           </a:xfrm>
           <a:prstGeom prst="rect">
             <a:avLst/>
           </a:prstGeom>
           <a:solidFill>
-            <a:srgbClr val="818CF8">
-              <a:alpha val="80000"/>
+            <a:srgbClr val="34D399">
+              <a:alpha val="15000"/>
             </a:srgbClr>
-          </a:solidFill>
-          <a:ln/>
-        </p:spPr>
-      </p:sp>
-      <p:sp>
-        <p:nvSpPr>
-          <p:cNvPr id="6" name="Text 4"/>
-          <p:cNvSpPr/>
-          <p:nvPr/>
-        </p:nvSpPr>
-        <p:spPr>
-          <a:xfrm>
-            <a:off x="411480" y="1261872"/>
-            <a:ext cx="2103120" cy="274320"/>
-          </a:xfrm>
-          <a:prstGeom prst="rect">
-            <a:avLst/>
-          </a:prstGeom>
-          <a:noFill/>
-          <a:ln/>
-        </p:spPr>
-        <p:txBody>
-          <a:bodyPr wrap="square" lIns="0" tIns="0" rIns="0" bIns="0" rtlCol="0" anchor="ctr"/>
-          <a:lstStyle/>
-          <a:p>
-            <a:pPr algn="ctr" indent="0" marL="0">
-              <a:buNone/>
-            </a:pPr>
-            <a:r>
-              <a:rPr lang="en-US" sz="1000" b="1" dirty="0">
-                <a:solidFill>
-                  <a:srgbClr val="FFFFFF"/>
-                </a:solidFill>
-                <a:latin typeface="Calibri" pitchFamily="34" charset="0"/>
-                <a:ea typeface="Calibri" pitchFamily="34" charset="-122"/>
-                <a:cs typeface="Calibri" pitchFamily="34" charset="-120"/>
-              </a:rPr>
-              <a:t>arXiv · 2503.19461  ·  2025</a:t>
-            </a:r>
-            <a:endParaRPr lang="en-US" sz="1000" dirty="0"/>
-          </a:p>
-        </p:txBody>
-      </p:sp>
-      <p:sp>
-        <p:nvSpPr>
-          <p:cNvPr id="7" name="Text 5"/>
-          <p:cNvSpPr/>
-          <p:nvPr/>
-        </p:nvSpPr>
-        <p:spPr>
-          <a:xfrm>
-            <a:off x="411480" y="1600200"/>
-            <a:ext cx="5029200" cy="237744"/>
-          </a:xfrm>
-          <a:prstGeom prst="rect">
-            <a:avLst/>
-          </a:prstGeom>
-          <a:noFill/>
-          <a:ln/>
-        </p:spPr>
-        <p:txBody>
-          <a:bodyPr wrap="square" lIns="0" tIns="0" rIns="0" bIns="0" rtlCol="0" anchor="ctr"/>
-          <a:lstStyle/>
-          <a:p>
-            <a:pPr indent="0" marL="0">
-              <a:buNone/>
-            </a:pPr>
-            <a:r>
-              <a:rPr lang="en-US" sz="1100" dirty="0">
-                <a:solidFill>
-                  <a:srgbClr val="94A3B8"/>
-                </a:solidFill>
-                <a:latin typeface="Calibri" pitchFamily="34" charset="0"/>
-                <a:ea typeface="Calibri" pitchFamily="34" charset="-122"/>
-                <a:cs typeface="Calibri" pitchFamily="34" charset="-120"/>
-              </a:rPr>
-              <a:t>Sakana AI  ·  Google DeepMind  ·  University of British Columbia</a:t>
-            </a:r>
-            <a:endParaRPr lang="en-US" sz="1100" dirty="0"/>
-          </a:p>
-        </p:txBody>
-      </p:sp>
-      <p:sp>
-        <p:nvSpPr>
-          <p:cNvPr id="8" name="Shape 6"/>
-          <p:cNvSpPr/>
-          <p:nvPr/>
-        </p:nvSpPr>
-        <p:spPr>
-          <a:xfrm>
-            <a:off x="411480" y="1920240"/>
-            <a:ext cx="5029200" cy="13716"/>
-          </a:xfrm>
-          <a:prstGeom prst="rect">
-            <a:avLst/>
-          </a:prstGeom>
-          <a:solidFill>
-            <a:srgbClr val="475569"/>
-          </a:solidFill>
-          <a:ln/>
-        </p:spPr>
-      </p:sp>
-      <p:sp>
-        <p:nvSpPr>
-          <p:cNvPr id="9" name="Text 7"/>
-          <p:cNvSpPr/>
-          <p:nvPr/>
-        </p:nvSpPr>
-        <p:spPr>
-          <a:xfrm>
-            <a:off x="411480" y="2011680"/>
-            <a:ext cx="1828800" cy="201168"/>
-          </a:xfrm>
-          <a:prstGeom prst="rect">
-            <a:avLst/>
-          </a:prstGeom>
-          <a:noFill/>
-          <a:ln/>
-        </p:spPr>
-        <p:txBody>
-          <a:bodyPr wrap="square" lIns="0" tIns="0" rIns="0" bIns="0" rtlCol="0" anchor="ctr"/>
-          <a:lstStyle/>
-          <a:p>
-            <a:pPr indent="0" marL="0">
-              <a:buNone/>
-            </a:pPr>
-            <a:r>
-              <a:rPr lang="en-US" sz="800" b="1" spc="300" kern="0" dirty="0">
-                <a:solidFill>
-                  <a:srgbClr val="818CF8"/>
-                </a:solidFill>
-                <a:latin typeface="Calibri" pitchFamily="34" charset="0"/>
-                <a:ea typeface="Calibri" pitchFamily="34" charset="-122"/>
-                <a:cs typeface="Calibri" pitchFamily="34" charset="-120"/>
-              </a:rPr>
-              <a:t>CORE IDEA</a:t>
-            </a:r>
-            <a:endParaRPr lang="en-US" sz="800" dirty="0"/>
-          </a:p>
-        </p:txBody>
-      </p:sp>
-      <p:sp>
-        <p:nvSpPr>
-          <p:cNvPr id="10" name="Text 8"/>
-          <p:cNvSpPr/>
-          <p:nvPr/>
-        </p:nvSpPr>
-        <p:spPr>
-          <a:xfrm>
-            <a:off x="411480" y="2249424"/>
-            <a:ext cx="5029200" cy="658368"/>
-          </a:xfrm>
-          <a:prstGeom prst="rect">
-            <a:avLst/>
-          </a:prstGeom>
-          <a:noFill/>
-          <a:ln/>
-        </p:spPr>
-        <p:txBody>
-          <a:bodyPr wrap="square" lIns="0" tIns="0" rIns="0" bIns="0" rtlCol="0" anchor="ctr"/>
-          <a:lstStyle/>
-          <a:p>
-            <a:pPr indent="0" marL="0">
-              <a:buNone/>
-            </a:pPr>
-            <a:r>
-              <a:rPr lang="en-US" sz="1200" dirty="0">
-                <a:solidFill>
-                  <a:srgbClr val="E2E8F0"/>
-                </a:solidFill>
-                <a:latin typeface="Calibri" pitchFamily="34" charset="0"/>
-                <a:ea typeface="Calibri" pitchFamily="34" charset="-122"/>
-                <a:cs typeface="Calibri" pitchFamily="34" charset="-120"/>
-              </a:rPr>
-              <a:t>An agent that iteratively rewrites its own code to improve performance — validated by an empirical eval gate before each new version is deployed. The meta-agent proposes a diff; the eval gate either approves or blocks it.</a:t>
-            </a:r>
-            <a:endParaRPr lang="en-US" sz="1200" dirty="0"/>
-          </a:p>
-        </p:txBody>
-      </p:sp>
-      <p:sp>
-        <p:nvSpPr>
-          <p:cNvPr id="11" name="Text 9"/>
-          <p:cNvSpPr/>
-          <p:nvPr/>
-        </p:nvSpPr>
-        <p:spPr>
-          <a:xfrm>
-            <a:off x="411480" y="2999232"/>
-            <a:ext cx="3200400" cy="201168"/>
-          </a:xfrm>
-          <a:prstGeom prst="rect">
-            <a:avLst/>
-          </a:prstGeom>
-          <a:noFill/>
-          <a:ln/>
-        </p:spPr>
-        <p:txBody>
-          <a:bodyPr wrap="square" lIns="0" tIns="0" rIns="0" bIns="0" rtlCol="0" anchor="ctr"/>
-          <a:lstStyle/>
-          <a:p>
-            <a:pPr indent="0" marL="0">
-              <a:buNone/>
-            </a:pPr>
-            <a:r>
-              <a:rPr lang="en-US" sz="800" b="1" spc="300" kern="0" dirty="0">
-                <a:solidFill>
-                  <a:srgbClr val="38BDF8"/>
-                </a:solidFill>
-                <a:latin typeface="Calibri" pitchFamily="34" charset="0"/>
-                <a:ea typeface="Calibri" pitchFamily="34" charset="-122"/>
-                <a:cs typeface="Calibri" pitchFamily="34" charset="-120"/>
-              </a:rPr>
-              <a:t>HOW INFRABRAIN MAPS TO IT</a:t>
-            </a:r>
-            <a:endParaRPr lang="en-US" sz="800" dirty="0"/>
-          </a:p>
-        </p:txBody>
-      </p:sp>
-      <p:sp>
-        <p:nvSpPr>
-          <p:cNvPr id="12" name="Shape 10"/>
-          <p:cNvSpPr/>
-          <p:nvPr/>
-        </p:nvSpPr>
-        <p:spPr>
-          <a:xfrm>
-            <a:off x="411480" y="3246120"/>
-            <a:ext cx="1645920" cy="274320"/>
-          </a:xfrm>
-          <a:prstGeom prst="rect">
-            <a:avLst/>
-          </a:prstGeom>
-          <a:solidFill>
-            <a:srgbClr val="131D30"/>
-          </a:solidFill>
-          <a:ln/>
-        </p:spPr>
-      </p:sp>
-      <p:sp>
-        <p:nvSpPr>
-          <p:cNvPr id="13" name="Text 11"/>
-          <p:cNvSpPr/>
-          <p:nvPr/>
-        </p:nvSpPr>
-        <p:spPr>
-          <a:xfrm>
-            <a:off x="411480" y="3246120"/>
-            <a:ext cx="1645920" cy="274320"/>
-          </a:xfrm>
-          <a:prstGeom prst="rect">
-            <a:avLst/>
-          </a:prstGeom>
-          <a:noFill/>
-          <a:ln/>
-        </p:spPr>
-        <p:txBody>
-          <a:bodyPr wrap="square" lIns="0" tIns="0" rIns="0" bIns="0" rtlCol="0" anchor="ctr"/>
-          <a:lstStyle/>
-          <a:p>
-            <a:pPr algn="ctr" indent="0" marL="0">
-              <a:buNone/>
-            </a:pPr>
-            <a:r>
-              <a:rPr lang="en-US" sz="1000" dirty="0">
-                <a:solidFill>
-                  <a:srgbClr val="818CF8"/>
-                </a:solidFill>
-                <a:latin typeface="Calibri" pitchFamily="34" charset="0"/>
-                <a:ea typeface="Calibri" pitchFamily="34" charset="-122"/>
-                <a:cs typeface="Calibri" pitchFamily="34" charset="-120"/>
-              </a:rPr>
-              <a:t>Meta-agent</a:t>
-            </a:r>
-            <a:endParaRPr lang="en-US" sz="1000" dirty="0"/>
-          </a:p>
-        </p:txBody>
-      </p:sp>
-      <p:sp>
-        <p:nvSpPr>
-          <p:cNvPr id="14" name="Text 12"/>
-          <p:cNvSpPr/>
-          <p:nvPr/>
-        </p:nvSpPr>
-        <p:spPr>
-          <a:xfrm>
-            <a:off x="2103120" y="3246120"/>
-            <a:ext cx="274320" cy="274320"/>
-          </a:xfrm>
-          <a:prstGeom prst="rect">
-            <a:avLst/>
-          </a:prstGeom>
-          <a:noFill/>
-          <a:ln/>
-        </p:spPr>
-        <p:txBody>
-          <a:bodyPr wrap="square" lIns="0" tIns="0" rIns="0" bIns="0" rtlCol="0" anchor="ctr"/>
-          <a:lstStyle/>
-          <a:p>
-            <a:pPr algn="ctr" indent="0" marL="0">
-              <a:buNone/>
-            </a:pPr>
-            <a:r>
-              <a:rPr lang="en-US" sz="1200" b="1" dirty="0">
-                <a:solidFill>
-                  <a:srgbClr val="475569"/>
-                </a:solidFill>
-                <a:latin typeface="Calibri" pitchFamily="34" charset="0"/>
-                <a:ea typeface="Calibri" pitchFamily="34" charset="-122"/>
-                <a:cs typeface="Calibri" pitchFamily="34" charset="-120"/>
-              </a:rPr>
-              <a:t>→</a:t>
-            </a:r>
-            <a:endParaRPr lang="en-US" sz="1200" dirty="0"/>
-          </a:p>
-        </p:txBody>
-      </p:sp>
-      <p:sp>
-        <p:nvSpPr>
-          <p:cNvPr id="15" name="Text 13"/>
-          <p:cNvSpPr/>
-          <p:nvPr/>
-        </p:nvSpPr>
-        <p:spPr>
-          <a:xfrm>
-            <a:off x="2423160" y="3246120"/>
-            <a:ext cx="3017520" cy="274320"/>
-          </a:xfrm>
-          <a:prstGeom prst="rect">
-            <a:avLst/>
-          </a:prstGeom>
-          <a:noFill/>
-          <a:ln/>
-        </p:spPr>
-        <p:txBody>
-          <a:bodyPr wrap="square" lIns="0" tIns="0" rIns="0" bIns="0" rtlCol="0" anchor="ctr"/>
-          <a:lstStyle/>
-          <a:p>
-            <a:pPr indent="0" marL="0">
-              <a:buNone/>
-            </a:pPr>
-            <a:r>
-              <a:rPr lang="en-US" sz="1000" dirty="0">
-                <a:solidFill>
-                  <a:srgbClr val="38BDF8"/>
-                </a:solidFill>
-                <a:latin typeface="Calibri" pitchFamily="34" charset="0"/>
-                <a:ea typeface="Calibri" pitchFamily="34" charset="-122"/>
-                <a:cs typeface="Calibri" pitchFamily="34" charset="-120"/>
-              </a:rPr>
-              <a:t>POST /api/meta   (InfraBrain backend)</a:t>
-            </a:r>
-            <a:endParaRPr lang="en-US" sz="1000" dirty="0"/>
-          </a:p>
-        </p:txBody>
-      </p:sp>
-      <p:sp>
-        <p:nvSpPr>
-          <p:cNvPr id="16" name="Shape 14"/>
-          <p:cNvSpPr/>
-          <p:nvPr/>
-        </p:nvSpPr>
-        <p:spPr>
-          <a:xfrm>
-            <a:off x="411480" y="3593592"/>
-            <a:ext cx="1645920" cy="274320"/>
-          </a:xfrm>
-          <a:prstGeom prst="rect">
-            <a:avLst/>
-          </a:prstGeom>
-          <a:solidFill>
-            <a:srgbClr val="131D30"/>
-          </a:solidFill>
-          <a:ln/>
-        </p:spPr>
-      </p:sp>
-      <p:sp>
-        <p:nvSpPr>
-          <p:cNvPr id="17" name="Text 15"/>
-          <p:cNvSpPr/>
-          <p:nvPr/>
-        </p:nvSpPr>
-        <p:spPr>
-          <a:xfrm>
-            <a:off x="411480" y="3593592"/>
-            <a:ext cx="1645920" cy="274320"/>
-          </a:xfrm>
-          <a:prstGeom prst="rect">
-            <a:avLst/>
-          </a:prstGeom>
-          <a:noFill/>
-          <a:ln/>
-        </p:spPr>
-        <p:txBody>
-          <a:bodyPr wrap="square" lIns="0" tIns="0" rIns="0" bIns="0" rtlCol="0" anchor="ctr"/>
-          <a:lstStyle/>
-          <a:p>
-            <a:pPr algn="ctr" indent="0" marL="0">
-              <a:buNone/>
-            </a:pPr>
-            <a:r>
-              <a:rPr lang="en-US" sz="1000" dirty="0">
-                <a:solidFill>
-                  <a:srgbClr val="818CF8"/>
-                </a:solidFill>
-                <a:latin typeface="Calibri" pitchFamily="34" charset="0"/>
-                <a:ea typeface="Calibri" pitchFamily="34" charset="-122"/>
-                <a:cs typeface="Calibri" pitchFamily="34" charset="-120"/>
-              </a:rPr>
-              <a:t>Code diff / rewrite</a:t>
-            </a:r>
-            <a:endParaRPr lang="en-US" sz="1000" dirty="0"/>
-          </a:p>
-        </p:txBody>
-      </p:sp>
-      <p:sp>
-        <p:nvSpPr>
-          <p:cNvPr id="18" name="Text 16"/>
-          <p:cNvSpPr/>
-          <p:nvPr/>
-        </p:nvSpPr>
-        <p:spPr>
-          <a:xfrm>
-            <a:off x="2103120" y="3593592"/>
-            <a:ext cx="274320" cy="274320"/>
-          </a:xfrm>
-          <a:prstGeom prst="rect">
-            <a:avLst/>
-          </a:prstGeom>
-          <a:noFill/>
-          <a:ln/>
-        </p:spPr>
-        <p:txBody>
-          <a:bodyPr wrap="square" lIns="0" tIns="0" rIns="0" bIns="0" rtlCol="0" anchor="ctr"/>
-          <a:lstStyle/>
-          <a:p>
-            <a:pPr algn="ctr" indent="0" marL="0">
-              <a:buNone/>
-            </a:pPr>
-            <a:r>
-              <a:rPr lang="en-US" sz="1200" b="1" dirty="0">
-                <a:solidFill>
-                  <a:srgbClr val="475569"/>
-                </a:solidFill>
-                <a:latin typeface="Calibri" pitchFamily="34" charset="0"/>
-                <a:ea typeface="Calibri" pitchFamily="34" charset="-122"/>
-                <a:cs typeface="Calibri" pitchFamily="34" charset="-120"/>
-              </a:rPr>
-              <a:t>→</a:t>
-            </a:r>
-            <a:endParaRPr lang="en-US" sz="1200" dirty="0"/>
-          </a:p>
-        </p:txBody>
-      </p:sp>
-      <p:sp>
-        <p:nvSpPr>
-          <p:cNvPr id="19" name="Text 17"/>
-          <p:cNvSpPr/>
-          <p:nvPr/>
-        </p:nvSpPr>
-        <p:spPr>
-          <a:xfrm>
-            <a:off x="2423160" y="3593592"/>
-            <a:ext cx="3017520" cy="274320"/>
-          </a:xfrm>
-          <a:prstGeom prst="rect">
-            <a:avLst/>
-          </a:prstGeom>
-          <a:noFill/>
-          <a:ln/>
-        </p:spPr>
-        <p:txBody>
-          <a:bodyPr wrap="square" lIns="0" tIns="0" rIns="0" bIns="0" rtlCol="0" anchor="ctr"/>
-          <a:lstStyle/>
-          <a:p>
-            <a:pPr indent="0" marL="0">
-              <a:buNone/>
-            </a:pPr>
-            <a:r>
-              <a:rPr lang="en-US" sz="1000" dirty="0">
-                <a:solidFill>
-                  <a:srgbClr val="38BDF8"/>
-                </a:solidFill>
-                <a:latin typeface="Calibri" pitchFamily="34" charset="0"/>
-                <a:ea typeface="Calibri" pitchFamily="34" charset="-122"/>
-                <a:cs typeface="Calibri" pitchFamily="34" charset="-120"/>
-              </a:rPr>
-              <a:t>Task-agent prompt rewrite from KG patterns</a:t>
-            </a:r>
-            <a:endParaRPr lang="en-US" sz="1000" dirty="0"/>
-          </a:p>
-        </p:txBody>
-      </p:sp>
-      <p:sp>
-        <p:nvSpPr>
-          <p:cNvPr id="20" name="Shape 18"/>
-          <p:cNvSpPr/>
-          <p:nvPr/>
-        </p:nvSpPr>
-        <p:spPr>
-          <a:xfrm>
-            <a:off x="411480" y="3941064"/>
-            <a:ext cx="1645920" cy="274320"/>
-          </a:xfrm>
-          <a:prstGeom prst="rect">
-            <a:avLst/>
-          </a:prstGeom>
-          <a:solidFill>
-            <a:srgbClr val="131D30"/>
-          </a:solidFill>
-          <a:ln/>
-        </p:spPr>
-      </p:sp>
-      <p:sp>
-        <p:nvSpPr>
-          <p:cNvPr id="21" name="Text 19"/>
-          <p:cNvSpPr/>
-          <p:nvPr/>
-        </p:nvSpPr>
-        <p:spPr>
-          <a:xfrm>
-            <a:off x="411480" y="3941064"/>
-            <a:ext cx="1645920" cy="274320"/>
-          </a:xfrm>
-          <a:prstGeom prst="rect">
-            <a:avLst/>
-          </a:prstGeom>
-          <a:noFill/>
-          <a:ln/>
-        </p:spPr>
-        <p:txBody>
-          <a:bodyPr wrap="square" lIns="0" tIns="0" rIns="0" bIns="0" rtlCol="0" anchor="ctr"/>
-          <a:lstStyle/>
-          <a:p>
-            <a:pPr algn="ctr" indent="0" marL="0">
-              <a:buNone/>
-            </a:pPr>
-            <a:r>
-              <a:rPr lang="en-US" sz="1000" dirty="0">
-                <a:solidFill>
-                  <a:srgbClr val="818CF8"/>
-                </a:solidFill>
-                <a:latin typeface="Calibri" pitchFamily="34" charset="0"/>
-                <a:ea typeface="Calibri" pitchFamily="34" charset="-122"/>
-                <a:cs typeface="Calibri" pitchFamily="34" charset="-120"/>
-              </a:rPr>
-              <a:t>Eval gate</a:t>
-            </a:r>
-            <a:endParaRPr lang="en-US" sz="1000" dirty="0"/>
-          </a:p>
-        </p:txBody>
-      </p:sp>
-      <p:sp>
-        <p:nvSpPr>
-          <p:cNvPr id="22" name="Text 20"/>
-          <p:cNvSpPr/>
-          <p:nvPr/>
-        </p:nvSpPr>
-        <p:spPr>
-          <a:xfrm>
-            <a:off x="2103120" y="3941064"/>
-            <a:ext cx="274320" cy="274320"/>
-          </a:xfrm>
-          <a:prstGeom prst="rect">
-            <a:avLst/>
-          </a:prstGeom>
-          <a:noFill/>
-          <a:ln/>
-        </p:spPr>
-        <p:txBody>
-          <a:bodyPr wrap="square" lIns="0" tIns="0" rIns="0" bIns="0" rtlCol="0" anchor="ctr"/>
-          <a:lstStyle/>
-          <a:p>
-            <a:pPr algn="ctr" indent="0" marL="0">
-              <a:buNone/>
-            </a:pPr>
-            <a:r>
-              <a:rPr lang="en-US" sz="1200" b="1" dirty="0">
-                <a:solidFill>
-                  <a:srgbClr val="475569"/>
-                </a:solidFill>
-                <a:latin typeface="Calibri" pitchFamily="34" charset="0"/>
-                <a:ea typeface="Calibri" pitchFamily="34" charset="-122"/>
-                <a:cs typeface="Calibri" pitchFamily="34" charset="-120"/>
-              </a:rPr>
-              <a:t>→</a:t>
-            </a:r>
-            <a:endParaRPr lang="en-US" sz="1200" dirty="0"/>
-          </a:p>
-        </p:txBody>
-      </p:sp>
-      <p:sp>
-        <p:nvSpPr>
-          <p:cNvPr id="23" name="Text 21"/>
-          <p:cNvSpPr/>
-          <p:nvPr/>
-        </p:nvSpPr>
-        <p:spPr>
-          <a:xfrm>
-            <a:off x="2423160" y="3941064"/>
-            <a:ext cx="3017520" cy="274320"/>
-          </a:xfrm>
-          <a:prstGeom prst="rect">
-            <a:avLst/>
-          </a:prstGeom>
-          <a:noFill/>
-          <a:ln/>
-        </p:spPr>
-        <p:txBody>
-          <a:bodyPr wrap="square" lIns="0" tIns="0" rIns="0" bIns="0" rtlCol="0" anchor="ctr"/>
-          <a:lstStyle/>
-          <a:p>
-            <a:pPr indent="0" marL="0">
-              <a:buNone/>
-            </a:pPr>
-            <a:r>
-              <a:rPr lang="en-US" sz="1000" dirty="0">
-                <a:solidFill>
-                  <a:srgbClr val="38BDF8"/>
-                </a:solidFill>
-                <a:latin typeface="Calibri" pitchFamily="34" charset="0"/>
-                <a:ea typeface="Calibri" pitchFamily="34" charset="-122"/>
-                <a:cs typeface="Calibri" pitchFamily="34" charset="-120"/>
-              </a:rPr>
-              <a:t>infrabrain-eval   (120 live Gemini API calls)</a:t>
-            </a:r>
-            <a:endParaRPr lang="en-US" sz="1000" dirty="0"/>
-          </a:p>
-        </p:txBody>
-      </p:sp>
-      <p:sp>
-        <p:nvSpPr>
-          <p:cNvPr id="24" name="Shape 22"/>
-          <p:cNvSpPr/>
-          <p:nvPr/>
-        </p:nvSpPr>
-        <p:spPr>
-          <a:xfrm>
-            <a:off x="411480" y="4288536"/>
-            <a:ext cx="1645920" cy="274320"/>
-          </a:xfrm>
-          <a:prstGeom prst="rect">
-            <a:avLst/>
-          </a:prstGeom>
-          <a:solidFill>
-            <a:srgbClr val="131D30"/>
-          </a:solidFill>
-          <a:ln/>
-        </p:spPr>
-      </p:sp>
-      <p:sp>
-        <p:nvSpPr>
-          <p:cNvPr id="25" name="Text 23"/>
-          <p:cNvSpPr/>
-          <p:nvPr/>
-        </p:nvSpPr>
-        <p:spPr>
-          <a:xfrm>
-            <a:off x="411480" y="4288536"/>
-            <a:ext cx="1645920" cy="274320"/>
-          </a:xfrm>
-          <a:prstGeom prst="rect">
-            <a:avLst/>
-          </a:prstGeom>
-          <a:noFill/>
-          <a:ln/>
-        </p:spPr>
-        <p:txBody>
-          <a:bodyPr wrap="square" lIns="0" tIns="0" rIns="0" bIns="0" rtlCol="0" anchor="ctr"/>
-          <a:lstStyle/>
-          <a:p>
-            <a:pPr algn="ctr" indent="0" marL="0">
-              <a:buNone/>
-            </a:pPr>
-            <a:r>
-              <a:rPr lang="en-US" sz="1000" dirty="0">
-                <a:solidFill>
-                  <a:srgbClr val="818CF8"/>
-                </a:solidFill>
-                <a:latin typeface="Calibri" pitchFamily="34" charset="0"/>
-                <a:ea typeface="Calibri" pitchFamily="34" charset="-122"/>
-                <a:cs typeface="Calibri" pitchFamily="34" charset="-120"/>
-              </a:rPr>
-              <a:t>Block regression</a:t>
-            </a:r>
-            <a:endParaRPr lang="en-US" sz="1000" dirty="0"/>
-          </a:p>
-        </p:txBody>
-      </p:sp>
-      <p:sp>
-        <p:nvSpPr>
-          <p:cNvPr id="26" name="Text 24"/>
-          <p:cNvSpPr/>
-          <p:nvPr/>
-        </p:nvSpPr>
-        <p:spPr>
-          <a:xfrm>
-            <a:off x="2103120" y="4288536"/>
-            <a:ext cx="274320" cy="274320"/>
-          </a:xfrm>
-          <a:prstGeom prst="rect">
-            <a:avLst/>
-          </a:prstGeom>
-          <a:noFill/>
-          <a:ln/>
-        </p:spPr>
-        <p:txBody>
-          <a:bodyPr wrap="square" lIns="0" tIns="0" rIns="0" bIns="0" rtlCol="0" anchor="ctr"/>
-          <a:lstStyle/>
-          <a:p>
-            <a:pPr algn="ctr" indent="0" marL="0">
-              <a:buNone/>
-            </a:pPr>
-            <a:r>
-              <a:rPr lang="en-US" sz="1200" b="1" dirty="0">
-                <a:solidFill>
-                  <a:srgbClr val="475569"/>
-                </a:solidFill>
-                <a:latin typeface="Calibri" pitchFamily="34" charset="0"/>
-                <a:ea typeface="Calibri" pitchFamily="34" charset="-122"/>
-                <a:cs typeface="Calibri" pitchFamily="34" charset="-120"/>
-              </a:rPr>
-              <a:t>→</a:t>
-            </a:r>
-            <a:endParaRPr lang="en-US" sz="1200" dirty="0"/>
-          </a:p>
-        </p:txBody>
-      </p:sp>
-      <p:sp>
-        <p:nvSpPr>
-          <p:cNvPr id="27" name="Text 25"/>
-          <p:cNvSpPr/>
-          <p:nvPr/>
-        </p:nvSpPr>
-        <p:spPr>
-          <a:xfrm>
-            <a:off x="2423160" y="4288536"/>
-            <a:ext cx="3017520" cy="274320"/>
-          </a:xfrm>
-          <a:prstGeom prst="rect">
-            <a:avLst/>
-          </a:prstGeom>
-          <a:noFill/>
-          <a:ln/>
-        </p:spPr>
-        <p:txBody>
-          <a:bodyPr wrap="square" lIns="0" tIns="0" rIns="0" bIns="0" rtlCol="0" anchor="ctr"/>
-          <a:lstStyle/>
-          <a:p>
-            <a:pPr indent="0" marL="0">
-              <a:buNone/>
-            </a:pPr>
-            <a:r>
-              <a:rPr lang="en-US" sz="1000" dirty="0">
-                <a:solidFill>
-                  <a:srgbClr val="38BDF8"/>
-                </a:solidFill>
-                <a:latin typeface="Calibri" pitchFamily="34" charset="0"/>
-                <a:ea typeface="Calibri" pitchFamily="34" charset="-122"/>
-                <a:cs typeface="Calibri" pitchFamily="34" charset="-120"/>
-              </a:rPr>
-              <a:t>Gen-5 CRITICAL NOTE caught before deploy</a:t>
-            </a:r>
-            <a:endParaRPr lang="en-US" sz="1000" dirty="0"/>
-          </a:p>
-        </p:txBody>
-      </p:sp>
-      <p:sp>
-        <p:nvSpPr>
-          <p:cNvPr id="28" name="Shape 26"/>
-          <p:cNvSpPr/>
-          <p:nvPr/>
-        </p:nvSpPr>
-        <p:spPr>
-          <a:xfrm>
-            <a:off x="5715000" y="548640"/>
-            <a:ext cx="3017520" cy="3931920"/>
-          </a:xfrm>
-          <a:prstGeom prst="rect">
-            <a:avLst/>
-          </a:prstGeom>
-          <a:solidFill>
-            <a:srgbClr val="131D30"/>
           </a:solidFill>
           <a:ln w="12700">
             <a:solidFill>
-              <a:srgbClr val="475569"/>
+              <a:srgbClr val="34D399"/>
             </a:solidFill>
-            <a:prstDash val="dash"/>
+            <a:prstDash val="solid"/>
           </a:ln>
         </p:spPr>
       </p:sp>
       <p:sp>
         <p:nvSpPr>
-          <p:cNvPr id="29" name="Text 27"/>
-          <p:cNvSpPr/>
-          <p:nvPr/>
-        </p:nvSpPr>
-        <p:spPr>
-          <a:xfrm>
-            <a:off x="5715000" y="2011680"/>
-            <a:ext cx="3017520" cy="914400"/>
+          <p:cNvPr id="7" name="Text 4"/>
+          <p:cNvSpPr/>
+          <p:nvPr/>
+        </p:nvSpPr>
+        <p:spPr>
+          <a:xfrm>
+            <a:off x="1005840" y="1344168"/>
+            <a:ext cx="1554480" cy="365760"/>
           </a:xfrm>
           <a:prstGeom prst="rect">
             <a:avLst/>
@@ -6545,7 +5689,446 @@
               <a:buNone/>
             </a:pPr>
             <a:r>
-              <a:rPr lang="en-US" sz="1300" dirty="0">
+              <a:rPr lang="en-US" sz="800" b="1" dirty="0">
+                <a:solidFill>
+                  <a:srgbClr val="34D399"/>
+                </a:solidFill>
+                <a:latin typeface="Calibri" pitchFamily="34" charset="0"/>
+                <a:ea typeface="Calibri" pitchFamily="34" charset="-122"/>
+                <a:cs typeface="Calibri" pitchFamily="34" charset="-120"/>
+              </a:rPr>
+              <a:t>30% → 5% override</a:t>
+            </a:r>
+            <a:endParaRPr lang="en-US" sz="800" dirty="0"/>
+          </a:p>
+          <a:p>
+            <a:pPr algn="ctr" indent="0" marL="0">
+              <a:buNone/>
+            </a:pPr>
+            <a:r>
+              <a:rPr lang="en-US" sz="800" b="1" dirty="0">
+                <a:solidFill>
+                  <a:srgbClr val="34D399"/>
+                </a:solidFill>
+                <a:latin typeface="Calibri" pitchFamily="34" charset="0"/>
+                <a:ea typeface="Calibri" pitchFamily="34" charset="-122"/>
+                <a:cs typeface="Calibri" pitchFamily="34" charset="-120"/>
+              </a:rPr>
+              <a:t>Biggest single jump</a:t>
+            </a:r>
+            <a:endParaRPr lang="en-US" sz="800" dirty="0"/>
+          </a:p>
+        </p:txBody>
+      </p:sp>
+      <p:sp>
+        <p:nvSpPr>
+          <p:cNvPr id="8" name="Shape 5"/>
+          <p:cNvSpPr/>
+          <p:nvPr/>
+        </p:nvSpPr>
+        <p:spPr>
+          <a:xfrm>
+            <a:off x="4160520" y="2971800"/>
+            <a:ext cx="1325880" cy="402336"/>
+          </a:xfrm>
+          <a:prstGeom prst="rect">
+            <a:avLst/>
+          </a:prstGeom>
+          <a:solidFill>
+            <a:srgbClr val="F87171">
+              <a:alpha val="15000"/>
+            </a:srgbClr>
+          </a:solidFill>
+          <a:ln w="12700">
+            <a:solidFill>
+              <a:srgbClr val="F87171"/>
+            </a:solidFill>
+            <a:prstDash val="solid"/>
+          </a:ln>
+        </p:spPr>
+      </p:sp>
+      <p:sp>
+        <p:nvSpPr>
+          <p:cNvPr id="9" name="Text 6"/>
+          <p:cNvSpPr/>
+          <p:nvPr/>
+        </p:nvSpPr>
+        <p:spPr>
+          <a:xfrm>
+            <a:off x="4160520" y="2990088"/>
+            <a:ext cx="1325880" cy="365760"/>
+          </a:xfrm>
+          <a:prstGeom prst="rect">
+            <a:avLst/>
+          </a:prstGeom>
+          <a:noFill/>
+          <a:ln/>
+        </p:spPr>
+        <p:txBody>
+          <a:bodyPr wrap="square" lIns="0" tIns="0" rIns="0" bIns="0" rtlCol="0" anchor="ctr"/>
+          <a:lstStyle/>
+          <a:p>
+            <a:pPr algn="ctr" indent="0" marL="0">
+              <a:buNone/>
+            </a:pPr>
+            <a:r>
+              <a:rPr lang="en-US" sz="800" b="1" dirty="0">
+                <a:solidFill>
+                  <a:srgbClr val="F87171"/>
+                </a:solidFill>
+                <a:latin typeface="Calibri" pitchFamily="34" charset="0"/>
+                <a:ea typeface="Calibri" pitchFamily="34" charset="-122"/>
+                <a:cs typeface="Calibri" pitchFamily="34" charset="-120"/>
+              </a:rPr>
+              <a:t>CRITICAL NOTE</a:t>
+            </a:r>
+            <a:endParaRPr lang="en-US" sz="800" dirty="0"/>
+          </a:p>
+          <a:p>
+            <a:pPr algn="ctr" indent="0" marL="0">
+              <a:buNone/>
+            </a:pPr>
+            <a:r>
+              <a:rPr lang="en-US" sz="800" b="1" dirty="0">
+                <a:solidFill>
+                  <a:srgbClr val="F87171"/>
+                </a:solidFill>
+                <a:latin typeface="Calibri" pitchFamily="34" charset="0"/>
+                <a:ea typeface="Calibri" pitchFamily="34" charset="-122"/>
+                <a:cs typeface="Calibri" pitchFamily="34" charset="-120"/>
+              </a:rPr>
+              <a:t>backfired ↓</a:t>
+            </a:r>
+            <a:endParaRPr lang="en-US" sz="800" dirty="0"/>
+          </a:p>
+        </p:txBody>
+      </p:sp>
+      <p:sp>
+        <p:nvSpPr>
+          <p:cNvPr id="10" name="Shape 7"/>
+          <p:cNvSpPr/>
+          <p:nvPr/>
+        </p:nvSpPr>
+        <p:spPr>
+          <a:xfrm>
+            <a:off x="5715000" y="1234440"/>
+            <a:ext cx="292608" cy="292608"/>
+          </a:xfrm>
+          <a:prstGeom prst="ellipse">
+            <a:avLst/>
+          </a:prstGeom>
+          <a:solidFill>
+            <a:srgbClr val="34D399">
+              <a:alpha val="20000"/>
+            </a:srgbClr>
+          </a:solidFill>
+          <a:ln/>
+        </p:spPr>
+      </p:sp>
+      <p:sp>
+        <p:nvSpPr>
+          <p:cNvPr id="11" name="Text 8"/>
+          <p:cNvSpPr/>
+          <p:nvPr/>
+        </p:nvSpPr>
+        <p:spPr>
+          <a:xfrm>
+            <a:off x="5715000" y="1234440"/>
+            <a:ext cx="292608" cy="292608"/>
+          </a:xfrm>
+          <a:prstGeom prst="rect">
+            <a:avLst/>
+          </a:prstGeom>
+          <a:noFill/>
+          <a:ln/>
+        </p:spPr>
+        <p:txBody>
+          <a:bodyPr wrap="square" lIns="0" tIns="0" rIns="0" bIns="0" rtlCol="0" anchor="ctr"/>
+          <a:lstStyle/>
+          <a:p>
+            <a:pPr algn="ctr" indent="0" marL="0">
+              <a:buNone/>
+            </a:pPr>
+            <a:r>
+              <a:rPr lang="en-US" sz="1200" dirty="0">
+                <a:solidFill>
+                  <a:srgbClr val="34D399"/>
+                </a:solidFill>
+                <a:latin typeface="Calibri" pitchFamily="34" charset="0"/>
+                <a:ea typeface="Calibri" pitchFamily="34" charset="-122"/>
+                <a:cs typeface="Calibri" pitchFamily="34" charset="-120"/>
+              </a:rPr>
+              <a:t>→</a:t>
+            </a:r>
+            <a:endParaRPr lang="en-US" sz="1200" dirty="0"/>
+          </a:p>
+        </p:txBody>
+      </p:sp>
+      <p:sp>
+        <p:nvSpPr>
+          <p:cNvPr id="12" name="Text 9"/>
+          <p:cNvSpPr/>
+          <p:nvPr/>
+        </p:nvSpPr>
+        <p:spPr>
+          <a:xfrm>
+            <a:off x="6080760" y="1216152"/>
+            <a:ext cx="2743200" cy="502920"/>
+          </a:xfrm>
+          <a:prstGeom prst="rect">
+            <a:avLst/>
+          </a:prstGeom>
+          <a:noFill/>
+          <a:ln/>
+        </p:spPr>
+        <p:txBody>
+          <a:bodyPr wrap="square" lIns="0" tIns="0" rIns="0" bIns="0" rtlCol="0" anchor="ctr"/>
+          <a:lstStyle/>
+          <a:p>
+            <a:pPr indent="0" marL="0">
+              <a:buNone/>
+            </a:pPr>
+            <a:r>
+              <a:rPr lang="en-US" sz="1050" dirty="0">
+                <a:solidFill>
+                  <a:srgbClr val="E2E8F0"/>
+                </a:solidFill>
+                <a:latin typeface="Calibri" pitchFamily="34" charset="0"/>
+                <a:ea typeface="Calibri" pitchFamily="34" charset="-122"/>
+                <a:cs typeface="Calibri" pitchFamily="34" charset="-120"/>
+              </a:rPr>
+              <a:t>Gen 0→1: One KG correction cut override rate from 30% to 5% — the learning signal works immediately</a:t>
+            </a:r>
+            <a:endParaRPr lang="en-US" sz="1050" dirty="0"/>
+          </a:p>
+        </p:txBody>
+      </p:sp>
+      <p:sp>
+        <p:nvSpPr>
+          <p:cNvPr id="13" name="Shape 10"/>
+          <p:cNvSpPr/>
+          <p:nvPr/>
+        </p:nvSpPr>
+        <p:spPr>
+          <a:xfrm>
+            <a:off x="5715000" y="2194560"/>
+            <a:ext cx="292608" cy="292608"/>
+          </a:xfrm>
+          <a:prstGeom prst="ellipse">
+            <a:avLst/>
+          </a:prstGeom>
+          <a:solidFill>
+            <a:srgbClr val="38BDF8">
+              <a:alpha val="20000"/>
+            </a:srgbClr>
+          </a:solidFill>
+          <a:ln/>
+        </p:spPr>
+      </p:sp>
+      <p:sp>
+        <p:nvSpPr>
+          <p:cNvPr id="14" name="Text 11"/>
+          <p:cNvSpPr/>
+          <p:nvPr/>
+        </p:nvSpPr>
+        <p:spPr>
+          <a:xfrm>
+            <a:off x="5715000" y="2194560"/>
+            <a:ext cx="292608" cy="292608"/>
+          </a:xfrm>
+          <a:prstGeom prst="rect">
+            <a:avLst/>
+          </a:prstGeom>
+          <a:noFill/>
+          <a:ln/>
+        </p:spPr>
+        <p:txBody>
+          <a:bodyPr wrap="square" lIns="0" tIns="0" rIns="0" bIns="0" rtlCol="0" anchor="ctr"/>
+          <a:lstStyle/>
+          <a:p>
+            <a:pPr algn="ctr" indent="0" marL="0">
+              <a:buNone/>
+            </a:pPr>
+            <a:r>
+              <a:rPr lang="en-US" sz="1200" dirty="0">
+                <a:solidFill>
+                  <a:srgbClr val="38BDF8"/>
+                </a:solidFill>
+                <a:latin typeface="Calibri" pitchFamily="34" charset="0"/>
+                <a:ea typeface="Calibri" pitchFamily="34" charset="-122"/>
+                <a:cs typeface="Calibri" pitchFamily="34" charset="-120"/>
+              </a:rPr>
+              <a:t>⚙</a:t>
+            </a:r>
+            <a:endParaRPr lang="en-US" sz="1200" dirty="0"/>
+          </a:p>
+        </p:txBody>
+      </p:sp>
+      <p:sp>
+        <p:nvSpPr>
+          <p:cNvPr id="15" name="Text 12"/>
+          <p:cNvSpPr/>
+          <p:nvPr/>
+        </p:nvSpPr>
+        <p:spPr>
+          <a:xfrm>
+            <a:off x="6080760" y="2176272"/>
+            <a:ext cx="2743200" cy="502920"/>
+          </a:xfrm>
+          <a:prstGeom prst="rect">
+            <a:avLst/>
+          </a:prstGeom>
+          <a:noFill/>
+          <a:ln/>
+        </p:spPr>
+        <p:txBody>
+          <a:bodyPr wrap="square" lIns="0" tIns="0" rIns="0" bIns="0" rtlCol="0" anchor="ctr"/>
+          <a:lstStyle/>
+          <a:p>
+            <a:pPr indent="0" marL="0">
+              <a:buNone/>
+            </a:pPr>
+            <a:r>
+              <a:rPr lang="en-US" sz="1050" dirty="0">
+                <a:solidFill>
+                  <a:srgbClr val="E2E8F0"/>
+                </a:solidFill>
+                <a:latin typeface="Calibri" pitchFamily="34" charset="0"/>
+                <a:ea typeface="Calibri" pitchFamily="34" charset="-122"/>
+                <a:cs typeface="Calibri" pitchFamily="34" charset="-120"/>
+              </a:rPr>
+              <a:t>Gen 4 is the best generation at 10% override — contradiction-check prompt is precise without over-steering</a:t>
+            </a:r>
+            <a:endParaRPr lang="en-US" sz="1050" dirty="0"/>
+          </a:p>
+        </p:txBody>
+      </p:sp>
+      <p:sp>
+        <p:nvSpPr>
+          <p:cNvPr id="16" name="Shape 13"/>
+          <p:cNvSpPr/>
+          <p:nvPr/>
+        </p:nvSpPr>
+        <p:spPr>
+          <a:xfrm>
+            <a:off x="5715000" y="3154680"/>
+            <a:ext cx="292608" cy="292608"/>
+          </a:xfrm>
+          <a:prstGeom prst="ellipse">
+            <a:avLst/>
+          </a:prstGeom>
+          <a:solidFill>
+            <a:srgbClr val="F87171">
+              <a:alpha val="20000"/>
+            </a:srgbClr>
+          </a:solidFill>
+          <a:ln/>
+        </p:spPr>
+      </p:sp>
+      <p:sp>
+        <p:nvSpPr>
+          <p:cNvPr id="17" name="Text 14"/>
+          <p:cNvSpPr/>
+          <p:nvPr/>
+        </p:nvSpPr>
+        <p:spPr>
+          <a:xfrm>
+            <a:off x="5715000" y="3154680"/>
+            <a:ext cx="292608" cy="292608"/>
+          </a:xfrm>
+          <a:prstGeom prst="rect">
+            <a:avLst/>
+          </a:prstGeom>
+          <a:noFill/>
+          <a:ln/>
+        </p:spPr>
+        <p:txBody>
+          <a:bodyPr wrap="square" lIns="0" tIns="0" rIns="0" bIns="0" rtlCol="0" anchor="ctr"/>
+          <a:lstStyle/>
+          <a:p>
+            <a:pPr algn="ctr" indent="0" marL="0">
+              <a:buNone/>
+            </a:pPr>
+            <a:r>
+              <a:rPr lang="en-US" sz="1200" dirty="0">
+                <a:solidFill>
+                  <a:srgbClr val="F87171"/>
+                </a:solidFill>
+                <a:latin typeface="Calibri" pitchFamily="34" charset="0"/>
+                <a:ea typeface="Calibri" pitchFamily="34" charset="-122"/>
+                <a:cs typeface="Calibri" pitchFamily="34" charset="-120"/>
+              </a:rPr>
+              <a:t>⛔</a:t>
+            </a:r>
+            <a:endParaRPr lang="en-US" sz="1200" dirty="0"/>
+          </a:p>
+        </p:txBody>
+      </p:sp>
+      <p:sp>
+        <p:nvSpPr>
+          <p:cNvPr id="18" name="Text 15"/>
+          <p:cNvSpPr/>
+          <p:nvPr/>
+        </p:nvSpPr>
+        <p:spPr>
+          <a:xfrm>
+            <a:off x="6080760" y="3136392"/>
+            <a:ext cx="2743200" cy="502920"/>
+          </a:xfrm>
+          <a:prstGeom prst="rect">
+            <a:avLst/>
+          </a:prstGeom>
+          <a:noFill/>
+          <a:ln/>
+        </p:spPr>
+        <p:txBody>
+          <a:bodyPr wrap="square" lIns="0" tIns="0" rIns="0" bIns="0" rtlCol="0" anchor="ctr"/>
+          <a:lstStyle/>
+          <a:p>
+            <a:pPr indent="0" marL="0">
+              <a:buNone/>
+            </a:pPr>
+            <a:r>
+              <a:rPr lang="en-US" sz="1050" dirty="0">
+                <a:solidFill>
+                  <a:srgbClr val="E2E8F0"/>
+                </a:solidFill>
+                <a:latin typeface="Calibri" pitchFamily="34" charset="0"/>
+                <a:ea typeface="Calibri" pitchFamily="34" charset="-122"/>
+                <a:cs typeface="Calibri" pitchFamily="34" charset="-120"/>
+              </a:rPr>
+              <a:t>Gen 5's CRITICAL NOTE backfired — over-steered the model on memory faults (25% override). Eval gate caught it before deployment</a:t>
+            </a:r>
+            <a:endParaRPr lang="en-US" sz="1050" dirty="0"/>
+          </a:p>
+        </p:txBody>
+      </p:sp>
+      <p:sp>
+        <p:nvSpPr>
+          <p:cNvPr id="19" name="Text 16"/>
+          <p:cNvSpPr/>
+          <p:nvPr/>
+        </p:nvSpPr>
+        <p:spPr>
+          <a:xfrm>
+            <a:off x="320040" y="4864608"/>
+            <a:ext cx="8503920" cy="182880"/>
+          </a:xfrm>
+          <a:prstGeom prst="rect">
+            <a:avLst/>
+          </a:prstGeom>
+          <a:noFill/>
+          <a:ln/>
+        </p:spPr>
+        <p:txBody>
+          <a:bodyPr wrap="square" lIns="0" tIns="0" rIns="0" bIns="0" rtlCol="0" anchor="ctr"/>
+          <a:lstStyle/>
+          <a:p>
+            <a:pPr algn="ctr" indent="0" marL="0">
+              <a:buNone/>
+            </a:pPr>
+            <a:r>
+              <a:rPr lang="en-US" sz="900" dirty="0">
                 <a:solidFill>
                   <a:srgbClr val="475569"/>
                 </a:solidFill>
@@ -6553,83 +6136,7 @@
                 <a:ea typeface="Calibri" pitchFamily="34" charset="-122"/>
                 <a:cs typeface="Calibri" pitchFamily="34" charset="-120"/>
               </a:rPr>
-              <a:t>[ Paper cover image</a:t>
-            </a:r>
-            <a:endParaRPr lang="en-US" sz="1300" dirty="0"/>
-          </a:p>
-          <a:p>
-            <a:pPr algn="ctr" indent="0" marL="0">
-              <a:buNone/>
-            </a:pPr>
-            <a:r>
-              <a:rPr lang="en-US" sz="1300" dirty="0">
-                <a:solidFill>
-                  <a:srgbClr val="475569"/>
-                </a:solidFill>
-                <a:latin typeface="Calibri" pitchFamily="34" charset="0"/>
-                <a:ea typeface="Calibri" pitchFamily="34" charset="-122"/>
-                <a:cs typeface="Calibri" pitchFamily="34" charset="-120"/>
-              </a:rPr>
-              <a:t>  — add here ]</a:t>
-            </a:r>
-            <a:endParaRPr lang="en-US" sz="1300" dirty="0"/>
-          </a:p>
-        </p:txBody>
-      </p:sp>
-      <p:sp>
-        <p:nvSpPr>
-          <p:cNvPr id="30" name="Shape 28"/>
-          <p:cNvSpPr/>
-          <p:nvPr/>
-        </p:nvSpPr>
-        <p:spPr>
-          <a:xfrm>
-            <a:off x="5715000" y="548640"/>
-            <a:ext cx="3017520" cy="54864"/>
-          </a:xfrm>
-          <a:prstGeom prst="rect">
-            <a:avLst/>
-          </a:prstGeom>
-          <a:solidFill>
-            <a:srgbClr val="818CF8"/>
-          </a:solidFill>
-          <a:ln/>
-        </p:spPr>
-      </p:sp>
-      <p:sp>
-        <p:nvSpPr>
-          <p:cNvPr id="31" name="Text 29"/>
-          <p:cNvSpPr/>
-          <p:nvPr/>
-        </p:nvSpPr>
-        <p:spPr>
-          <a:xfrm>
-            <a:off x="411480" y="4864608"/>
-            <a:ext cx="8321040" cy="164592"/>
-          </a:xfrm>
-          <a:prstGeom prst="rect">
-            <a:avLst/>
-          </a:prstGeom>
-          <a:noFill/>
-          <a:ln/>
-        </p:spPr>
-        <p:txBody>
-          <a:bodyPr wrap="square" lIns="0" tIns="0" rIns="0" bIns="0" rtlCol="0" anchor="ctr"/>
-          <a:lstStyle/>
-          <a:p>
-            <a:pPr indent="0" marL="0">
-              <a:buNone/>
-            </a:pPr>
-            <a:r>
-              <a:rPr lang="en-US" sz="900" dirty="0">
-                <a:solidFill>
-                  <a:srgbClr val="475569"/>
-                </a:solidFill>
-                <a:latin typeface="Calibri" pitchFamily="34" charset="0"/>
-                <a:ea typeface="Calibri" pitchFamily="34" charset="-122"/>
-                <a:cs typeface="Calibri" pitchFamily="34" charset="-120"/>
-              </a:rPr>
-              <a:t>arxiv.org/abs/2503.19461</a:t>
+              <a:t>Composite score = 0.40×accuracy + 0.25×MTTR + 0.20×override penalty + 0.15×safety</a:t>
             </a:r>
             <a:endParaRPr lang="en-US" sz="900" dirty="0"/>
           </a:p>
@@ -6646,650 +6153,6 @@
 <file path=ppt/slides/slide6.xml><?xml version="1.0" encoding="utf-8"?>
 <p:sld xmlns:a="http://schemas.openxmlformats.org/drawingml/2006/main" xmlns:r="http://schemas.openxmlformats.org/officeDocument/2006/relationships" xmlns:p="http://schemas.openxmlformats.org/presentationml/2006/main">
   <p:cSld name="Slide 6">
-    <p:spTree>
-      <p:nvGrpSpPr>
-        <p:cNvPr id="1" name=""/>
-        <p:cNvGrpSpPr/>
-        <p:nvPr/>
-      </p:nvGrpSpPr>
-      <p:grpSpPr>
-        <a:xfrm>
-          <a:off x="0" y="0"/>
-          <a:ext cx="0" cy="0"/>
-          <a:chOff x="0" y="0"/>
-          <a:chExt cx="0" cy="0"/>
-        </a:xfrm>
-      </p:grpSpPr>
-      <p:sp>
-        <p:nvSpPr>
-          <p:cNvPr id="2" name="Shape 0"/>
-          <p:cNvSpPr/>
-          <p:nvPr/>
-        </p:nvSpPr>
-        <p:spPr>
-          <a:xfrm>
-            <a:off x="0" y="0"/>
-            <a:ext cx="9144000" cy="5143500"/>
-          </a:xfrm>
-          <a:prstGeom prst="rect">
-            <a:avLst/>
-          </a:prstGeom>
-          <a:solidFill>
-            <a:srgbClr val="0A0F1E"/>
-          </a:solidFill>
-          <a:ln/>
-        </p:spPr>
-      </p:sp>
-      <p:sp>
-        <p:nvSpPr>
-          <p:cNvPr id="3" name="Text 1"/>
-          <p:cNvSpPr/>
-          <p:nvPr/>
-        </p:nvSpPr>
-        <p:spPr>
-          <a:xfrm>
-            <a:off x="411480" y="274320"/>
-            <a:ext cx="2743200" cy="201168"/>
-          </a:xfrm>
-          <a:prstGeom prst="rect">
-            <a:avLst/>
-          </a:prstGeom>
-          <a:noFill/>
-          <a:ln/>
-        </p:spPr>
-        <p:txBody>
-          <a:bodyPr wrap="square" rtlCol="0" anchor="ctr"/>
-          <a:lstStyle/>
-          <a:p>
-            <a:pPr indent="0" marL="0">
-              <a:buNone/>
-            </a:pPr>
-            <a:r>
-              <a:rPr lang="en-US" sz="900" b="1" spc="400" kern="0" dirty="0">
-                <a:solidFill>
-                  <a:srgbClr val="38BDF8"/>
-                </a:solidFill>
-                <a:latin typeface="Calibri" pitchFamily="34" charset="0"/>
-                <a:ea typeface="Calibri" pitchFamily="34" charset="-122"/>
-                <a:cs typeface="Calibri" pitchFamily="34" charset="-120"/>
-              </a:rPr>
-              <a:t>PART 2  ·  REAL RESULTS — 120 GEMINI API CALLS</a:t>
-            </a:r>
-            <a:endParaRPr lang="en-US" sz="900" dirty="0"/>
-          </a:p>
-        </p:txBody>
-      </p:sp>
-      <p:sp>
-        <p:nvSpPr>
-          <p:cNvPr id="4" name="Text 2"/>
-          <p:cNvSpPr/>
-          <p:nvPr/>
-        </p:nvSpPr>
-        <p:spPr>
-          <a:xfrm>
-            <a:off x="411480" y="548640"/>
-            <a:ext cx="8321040" cy="548640"/>
-          </a:xfrm>
-          <a:prstGeom prst="rect">
-            <a:avLst/>
-          </a:prstGeom>
-          <a:noFill/>
-          <a:ln/>
-        </p:spPr>
-        <p:txBody>
-          <a:bodyPr wrap="square" lIns="0" tIns="0" rIns="0" bIns="0" rtlCol="0" anchor="ctr"/>
-          <a:lstStyle/>
-          <a:p>
-            <a:pPr indent="0" marL="0">
-              <a:buNone/>
-            </a:pPr>
-            <a:r>
-              <a:rPr lang="en-US" sz="2600" b="1" dirty="0">
-                <a:solidFill>
-                  <a:srgbClr val="FFFFFF"/>
-                </a:solidFill>
-                <a:latin typeface="Calibri" pitchFamily="34" charset="0"/>
-                <a:ea typeface="Calibri" pitchFamily="34" charset="-122"/>
-                <a:cs typeface="Calibri" pitchFamily="34" charset="-120"/>
-              </a:rPr>
-              <a:t>KG corrections work. The eval gate catches what doesn't.</a:t>
-            </a:r>
-            <a:endParaRPr lang="en-US" sz="2600" dirty="0"/>
-          </a:p>
-        </p:txBody>
-      </p:sp>
-      <p:graphicFrame>
-        <p:nvGraphicFramePr>
-          <p:cNvPr id="5" name="Chart 0" descr=""/>
-          <p:cNvGraphicFramePr/>
-          <p:nvPr/>
-        </p:nvGraphicFramePr>
-        <p:xfrm>
-          <a:off x="320040" y="1188720"/>
-          <a:ext cx="5212080" cy="3200400"/>
-        </p:xfrm>
-        <a:graphic xmlns:a="http://schemas.openxmlformats.org/drawingml/2006/main">
-          <a:graphicData uri="http://schemas.openxmlformats.org/drawingml/2006/chart">
-            <c:chart xmlns:c="http://schemas.openxmlformats.org/drawingml/2006/chart" r:id="rId1"/>
-          </a:graphicData>
-        </a:graphic>
-      </p:graphicFrame>
-      <p:sp>
-        <p:nvSpPr>
-          <p:cNvPr id="6" name="Shape 3"/>
-          <p:cNvSpPr/>
-          <p:nvPr/>
-        </p:nvSpPr>
-        <p:spPr>
-          <a:xfrm>
-            <a:off x="1005840" y="1325880"/>
-            <a:ext cx="1554480" cy="402336"/>
-          </a:xfrm>
-          <a:prstGeom prst="rect">
-            <a:avLst/>
-          </a:prstGeom>
-          <a:solidFill>
-            <a:srgbClr val="34D399">
-              <a:alpha val="15000"/>
-            </a:srgbClr>
-          </a:solidFill>
-          <a:ln w="12700">
-            <a:solidFill>
-              <a:srgbClr val="34D399"/>
-            </a:solidFill>
-            <a:prstDash val="solid"/>
-          </a:ln>
-        </p:spPr>
-      </p:sp>
-      <p:sp>
-        <p:nvSpPr>
-          <p:cNvPr id="7" name="Text 4"/>
-          <p:cNvSpPr/>
-          <p:nvPr/>
-        </p:nvSpPr>
-        <p:spPr>
-          <a:xfrm>
-            <a:off x="1005840" y="1344168"/>
-            <a:ext cx="1554480" cy="365760"/>
-          </a:xfrm>
-          <a:prstGeom prst="rect">
-            <a:avLst/>
-          </a:prstGeom>
-          <a:noFill/>
-          <a:ln/>
-        </p:spPr>
-        <p:txBody>
-          <a:bodyPr wrap="square" lIns="0" tIns="0" rIns="0" bIns="0" rtlCol="0" anchor="ctr"/>
-          <a:lstStyle/>
-          <a:p>
-            <a:pPr algn="ctr" indent="0" marL="0">
-              <a:buNone/>
-            </a:pPr>
-            <a:r>
-              <a:rPr lang="en-US" sz="800" b="1" dirty="0">
-                <a:solidFill>
-                  <a:srgbClr val="34D399"/>
-                </a:solidFill>
-                <a:latin typeface="Calibri" pitchFamily="34" charset="0"/>
-                <a:ea typeface="Calibri" pitchFamily="34" charset="-122"/>
-                <a:cs typeface="Calibri" pitchFamily="34" charset="-120"/>
-              </a:rPr>
-              <a:t>30% → 5% override</a:t>
-            </a:r>
-            <a:endParaRPr lang="en-US" sz="800" dirty="0"/>
-          </a:p>
-          <a:p>
-            <a:pPr algn="ctr" indent="0" marL="0">
-              <a:buNone/>
-            </a:pPr>
-            <a:r>
-              <a:rPr lang="en-US" sz="800" b="1" dirty="0">
-                <a:solidFill>
-                  <a:srgbClr val="34D399"/>
-                </a:solidFill>
-                <a:latin typeface="Calibri" pitchFamily="34" charset="0"/>
-                <a:ea typeface="Calibri" pitchFamily="34" charset="-122"/>
-                <a:cs typeface="Calibri" pitchFamily="34" charset="-120"/>
-              </a:rPr>
-              <a:t>Biggest single jump</a:t>
-            </a:r>
-            <a:endParaRPr lang="en-US" sz="800" dirty="0"/>
-          </a:p>
-        </p:txBody>
-      </p:sp>
-      <p:sp>
-        <p:nvSpPr>
-          <p:cNvPr id="8" name="Shape 5"/>
-          <p:cNvSpPr/>
-          <p:nvPr/>
-        </p:nvSpPr>
-        <p:spPr>
-          <a:xfrm>
-            <a:off x="4160520" y="2971800"/>
-            <a:ext cx="1325880" cy="402336"/>
-          </a:xfrm>
-          <a:prstGeom prst="rect">
-            <a:avLst/>
-          </a:prstGeom>
-          <a:solidFill>
-            <a:srgbClr val="F87171">
-              <a:alpha val="15000"/>
-            </a:srgbClr>
-          </a:solidFill>
-          <a:ln w="12700">
-            <a:solidFill>
-              <a:srgbClr val="F87171"/>
-            </a:solidFill>
-            <a:prstDash val="solid"/>
-          </a:ln>
-        </p:spPr>
-      </p:sp>
-      <p:sp>
-        <p:nvSpPr>
-          <p:cNvPr id="9" name="Text 6"/>
-          <p:cNvSpPr/>
-          <p:nvPr/>
-        </p:nvSpPr>
-        <p:spPr>
-          <a:xfrm>
-            <a:off x="4160520" y="2990088"/>
-            <a:ext cx="1325880" cy="365760"/>
-          </a:xfrm>
-          <a:prstGeom prst="rect">
-            <a:avLst/>
-          </a:prstGeom>
-          <a:noFill/>
-          <a:ln/>
-        </p:spPr>
-        <p:txBody>
-          <a:bodyPr wrap="square" lIns="0" tIns="0" rIns="0" bIns="0" rtlCol="0" anchor="ctr"/>
-          <a:lstStyle/>
-          <a:p>
-            <a:pPr algn="ctr" indent="0" marL="0">
-              <a:buNone/>
-            </a:pPr>
-            <a:r>
-              <a:rPr lang="en-US" sz="800" b="1" dirty="0">
-                <a:solidFill>
-                  <a:srgbClr val="F87171"/>
-                </a:solidFill>
-                <a:latin typeface="Calibri" pitchFamily="34" charset="0"/>
-                <a:ea typeface="Calibri" pitchFamily="34" charset="-122"/>
-                <a:cs typeface="Calibri" pitchFamily="34" charset="-120"/>
-              </a:rPr>
-              <a:t>CRITICAL NOTE</a:t>
-            </a:r>
-            <a:endParaRPr lang="en-US" sz="800" dirty="0"/>
-          </a:p>
-          <a:p>
-            <a:pPr algn="ctr" indent="0" marL="0">
-              <a:buNone/>
-            </a:pPr>
-            <a:r>
-              <a:rPr lang="en-US" sz="800" b="1" dirty="0">
-                <a:solidFill>
-                  <a:srgbClr val="F87171"/>
-                </a:solidFill>
-                <a:latin typeface="Calibri" pitchFamily="34" charset="0"/>
-                <a:ea typeface="Calibri" pitchFamily="34" charset="-122"/>
-                <a:cs typeface="Calibri" pitchFamily="34" charset="-120"/>
-              </a:rPr>
-              <a:t>backfired ↓</a:t>
-            </a:r>
-            <a:endParaRPr lang="en-US" sz="800" dirty="0"/>
-          </a:p>
-        </p:txBody>
-      </p:sp>
-      <p:sp>
-        <p:nvSpPr>
-          <p:cNvPr id="10" name="Shape 7"/>
-          <p:cNvSpPr/>
-          <p:nvPr/>
-        </p:nvSpPr>
-        <p:spPr>
-          <a:xfrm>
-            <a:off x="5715000" y="1234440"/>
-            <a:ext cx="292608" cy="292608"/>
-          </a:xfrm>
-          <a:prstGeom prst="ellipse">
-            <a:avLst/>
-          </a:prstGeom>
-          <a:solidFill>
-            <a:srgbClr val="34D399">
-              <a:alpha val="20000"/>
-            </a:srgbClr>
-          </a:solidFill>
-          <a:ln/>
-        </p:spPr>
-      </p:sp>
-      <p:sp>
-        <p:nvSpPr>
-          <p:cNvPr id="11" name="Text 8"/>
-          <p:cNvSpPr/>
-          <p:nvPr/>
-        </p:nvSpPr>
-        <p:spPr>
-          <a:xfrm>
-            <a:off x="5715000" y="1234440"/>
-            <a:ext cx="292608" cy="292608"/>
-          </a:xfrm>
-          <a:prstGeom prst="rect">
-            <a:avLst/>
-          </a:prstGeom>
-          <a:noFill/>
-          <a:ln/>
-        </p:spPr>
-        <p:txBody>
-          <a:bodyPr wrap="square" lIns="0" tIns="0" rIns="0" bIns="0" rtlCol="0" anchor="ctr"/>
-          <a:lstStyle/>
-          <a:p>
-            <a:pPr algn="ctr" indent="0" marL="0">
-              <a:buNone/>
-            </a:pPr>
-            <a:r>
-              <a:rPr lang="en-US" sz="1200" dirty="0">
-                <a:solidFill>
-                  <a:srgbClr val="34D399"/>
-                </a:solidFill>
-                <a:latin typeface="Calibri" pitchFamily="34" charset="0"/>
-                <a:ea typeface="Calibri" pitchFamily="34" charset="-122"/>
-                <a:cs typeface="Calibri" pitchFamily="34" charset="-120"/>
-              </a:rPr>
-              <a:t>→</a:t>
-            </a:r>
-            <a:endParaRPr lang="en-US" sz="1200" dirty="0"/>
-          </a:p>
-        </p:txBody>
-      </p:sp>
-      <p:sp>
-        <p:nvSpPr>
-          <p:cNvPr id="12" name="Text 9"/>
-          <p:cNvSpPr/>
-          <p:nvPr/>
-        </p:nvSpPr>
-        <p:spPr>
-          <a:xfrm>
-            <a:off x="6080760" y="1216152"/>
-            <a:ext cx="2743200" cy="502920"/>
-          </a:xfrm>
-          <a:prstGeom prst="rect">
-            <a:avLst/>
-          </a:prstGeom>
-          <a:noFill/>
-          <a:ln/>
-        </p:spPr>
-        <p:txBody>
-          <a:bodyPr wrap="square" lIns="0" tIns="0" rIns="0" bIns="0" rtlCol="0" anchor="ctr"/>
-          <a:lstStyle/>
-          <a:p>
-            <a:pPr indent="0" marL="0">
-              <a:buNone/>
-            </a:pPr>
-            <a:r>
-              <a:rPr lang="en-US" sz="1050" dirty="0">
-                <a:solidFill>
-                  <a:srgbClr val="E2E8F0"/>
-                </a:solidFill>
-                <a:latin typeface="Calibri" pitchFamily="34" charset="0"/>
-                <a:ea typeface="Calibri" pitchFamily="34" charset="-122"/>
-                <a:cs typeface="Calibri" pitchFamily="34" charset="-120"/>
-              </a:rPr>
-              <a:t>Gen 0→1: One KG correction cut override rate from 30% to 5% — the learning signal works immediately</a:t>
-            </a:r>
-            <a:endParaRPr lang="en-US" sz="1050" dirty="0"/>
-          </a:p>
-        </p:txBody>
-      </p:sp>
-      <p:sp>
-        <p:nvSpPr>
-          <p:cNvPr id="13" name="Shape 10"/>
-          <p:cNvSpPr/>
-          <p:nvPr/>
-        </p:nvSpPr>
-        <p:spPr>
-          <a:xfrm>
-            <a:off x="5715000" y="2194560"/>
-            <a:ext cx="292608" cy="292608"/>
-          </a:xfrm>
-          <a:prstGeom prst="ellipse">
-            <a:avLst/>
-          </a:prstGeom>
-          <a:solidFill>
-            <a:srgbClr val="38BDF8">
-              <a:alpha val="20000"/>
-            </a:srgbClr>
-          </a:solidFill>
-          <a:ln/>
-        </p:spPr>
-      </p:sp>
-      <p:sp>
-        <p:nvSpPr>
-          <p:cNvPr id="14" name="Text 11"/>
-          <p:cNvSpPr/>
-          <p:nvPr/>
-        </p:nvSpPr>
-        <p:spPr>
-          <a:xfrm>
-            <a:off x="5715000" y="2194560"/>
-            <a:ext cx="292608" cy="292608"/>
-          </a:xfrm>
-          <a:prstGeom prst="rect">
-            <a:avLst/>
-          </a:prstGeom>
-          <a:noFill/>
-          <a:ln/>
-        </p:spPr>
-        <p:txBody>
-          <a:bodyPr wrap="square" lIns="0" tIns="0" rIns="0" bIns="0" rtlCol="0" anchor="ctr"/>
-          <a:lstStyle/>
-          <a:p>
-            <a:pPr algn="ctr" indent="0" marL="0">
-              <a:buNone/>
-            </a:pPr>
-            <a:r>
-              <a:rPr lang="en-US" sz="1200" dirty="0">
-                <a:solidFill>
-                  <a:srgbClr val="38BDF8"/>
-                </a:solidFill>
-                <a:latin typeface="Calibri" pitchFamily="34" charset="0"/>
-                <a:ea typeface="Calibri" pitchFamily="34" charset="-122"/>
-                <a:cs typeface="Calibri" pitchFamily="34" charset="-120"/>
-              </a:rPr>
-              <a:t>⚙</a:t>
-            </a:r>
-            <a:endParaRPr lang="en-US" sz="1200" dirty="0"/>
-          </a:p>
-        </p:txBody>
-      </p:sp>
-      <p:sp>
-        <p:nvSpPr>
-          <p:cNvPr id="15" name="Text 12"/>
-          <p:cNvSpPr/>
-          <p:nvPr/>
-        </p:nvSpPr>
-        <p:spPr>
-          <a:xfrm>
-            <a:off x="6080760" y="2176272"/>
-            <a:ext cx="2743200" cy="502920"/>
-          </a:xfrm>
-          <a:prstGeom prst="rect">
-            <a:avLst/>
-          </a:prstGeom>
-          <a:noFill/>
-          <a:ln/>
-        </p:spPr>
-        <p:txBody>
-          <a:bodyPr wrap="square" lIns="0" tIns="0" rIns="0" bIns="0" rtlCol="0" anchor="ctr"/>
-          <a:lstStyle/>
-          <a:p>
-            <a:pPr indent="0" marL="0">
-              <a:buNone/>
-            </a:pPr>
-            <a:r>
-              <a:rPr lang="en-US" sz="1050" dirty="0">
-                <a:solidFill>
-                  <a:srgbClr val="E2E8F0"/>
-                </a:solidFill>
-                <a:latin typeface="Calibri" pitchFamily="34" charset="0"/>
-                <a:ea typeface="Calibri" pitchFamily="34" charset="-122"/>
-                <a:cs typeface="Calibri" pitchFamily="34" charset="-120"/>
-              </a:rPr>
-              <a:t>Gen 4 is the best generation at 10% override — contradiction-check prompt is precise without over-steering</a:t>
-            </a:r>
-            <a:endParaRPr lang="en-US" sz="1050" dirty="0"/>
-          </a:p>
-        </p:txBody>
-      </p:sp>
-      <p:sp>
-        <p:nvSpPr>
-          <p:cNvPr id="16" name="Shape 13"/>
-          <p:cNvSpPr/>
-          <p:nvPr/>
-        </p:nvSpPr>
-        <p:spPr>
-          <a:xfrm>
-            <a:off x="5715000" y="3154680"/>
-            <a:ext cx="292608" cy="292608"/>
-          </a:xfrm>
-          <a:prstGeom prst="ellipse">
-            <a:avLst/>
-          </a:prstGeom>
-          <a:solidFill>
-            <a:srgbClr val="F87171">
-              <a:alpha val="20000"/>
-            </a:srgbClr>
-          </a:solidFill>
-          <a:ln/>
-        </p:spPr>
-      </p:sp>
-      <p:sp>
-        <p:nvSpPr>
-          <p:cNvPr id="17" name="Text 14"/>
-          <p:cNvSpPr/>
-          <p:nvPr/>
-        </p:nvSpPr>
-        <p:spPr>
-          <a:xfrm>
-            <a:off x="5715000" y="3154680"/>
-            <a:ext cx="292608" cy="292608"/>
-          </a:xfrm>
-          <a:prstGeom prst="rect">
-            <a:avLst/>
-          </a:prstGeom>
-          <a:noFill/>
-          <a:ln/>
-        </p:spPr>
-        <p:txBody>
-          <a:bodyPr wrap="square" lIns="0" tIns="0" rIns="0" bIns="0" rtlCol="0" anchor="ctr"/>
-          <a:lstStyle/>
-          <a:p>
-            <a:pPr algn="ctr" indent="0" marL="0">
-              <a:buNone/>
-            </a:pPr>
-            <a:r>
-              <a:rPr lang="en-US" sz="1200" dirty="0">
-                <a:solidFill>
-                  <a:srgbClr val="F87171"/>
-                </a:solidFill>
-                <a:latin typeface="Calibri" pitchFamily="34" charset="0"/>
-                <a:ea typeface="Calibri" pitchFamily="34" charset="-122"/>
-                <a:cs typeface="Calibri" pitchFamily="34" charset="-120"/>
-              </a:rPr>
-              <a:t>⛔</a:t>
-            </a:r>
-            <a:endParaRPr lang="en-US" sz="1200" dirty="0"/>
-          </a:p>
-        </p:txBody>
-      </p:sp>
-      <p:sp>
-        <p:nvSpPr>
-          <p:cNvPr id="18" name="Text 15"/>
-          <p:cNvSpPr/>
-          <p:nvPr/>
-        </p:nvSpPr>
-        <p:spPr>
-          <a:xfrm>
-            <a:off x="6080760" y="3136392"/>
-            <a:ext cx="2743200" cy="502920"/>
-          </a:xfrm>
-          <a:prstGeom prst="rect">
-            <a:avLst/>
-          </a:prstGeom>
-          <a:noFill/>
-          <a:ln/>
-        </p:spPr>
-        <p:txBody>
-          <a:bodyPr wrap="square" lIns="0" tIns="0" rIns="0" bIns="0" rtlCol="0" anchor="ctr"/>
-          <a:lstStyle/>
-          <a:p>
-            <a:pPr indent="0" marL="0">
-              <a:buNone/>
-            </a:pPr>
-            <a:r>
-              <a:rPr lang="en-US" sz="1050" dirty="0">
-                <a:solidFill>
-                  <a:srgbClr val="E2E8F0"/>
-                </a:solidFill>
-                <a:latin typeface="Calibri" pitchFamily="34" charset="0"/>
-                <a:ea typeface="Calibri" pitchFamily="34" charset="-122"/>
-                <a:cs typeface="Calibri" pitchFamily="34" charset="-120"/>
-              </a:rPr>
-              <a:t>Gen 5's CRITICAL NOTE backfired — over-steered the model on memory faults (25% override). Eval gate caught it before deployment</a:t>
-            </a:r>
-            <a:endParaRPr lang="en-US" sz="1050" dirty="0"/>
-          </a:p>
-        </p:txBody>
-      </p:sp>
-      <p:sp>
-        <p:nvSpPr>
-          <p:cNvPr id="19" name="Text 16"/>
-          <p:cNvSpPr/>
-          <p:nvPr/>
-        </p:nvSpPr>
-        <p:spPr>
-          <a:xfrm>
-            <a:off x="320040" y="4864608"/>
-            <a:ext cx="8503920" cy="182880"/>
-          </a:xfrm>
-          <a:prstGeom prst="rect">
-            <a:avLst/>
-          </a:prstGeom>
-          <a:noFill/>
-          <a:ln/>
-        </p:spPr>
-        <p:txBody>
-          <a:bodyPr wrap="square" lIns="0" tIns="0" rIns="0" bIns="0" rtlCol="0" anchor="ctr"/>
-          <a:lstStyle/>
-          <a:p>
-            <a:pPr algn="ctr" indent="0" marL="0">
-              <a:buNone/>
-            </a:pPr>
-            <a:r>
-              <a:rPr lang="en-US" sz="900" dirty="0">
-                <a:solidFill>
-                  <a:srgbClr val="475569"/>
-                </a:solidFill>
-                <a:latin typeface="Calibri" pitchFamily="34" charset="0"/>
-                <a:ea typeface="Calibri" pitchFamily="34" charset="-122"/>
-                <a:cs typeface="Calibri" pitchFamily="34" charset="-120"/>
-              </a:rPr>
-              <a:t>Composite score = 0.40×accuracy + 0.25×MTTR + 0.20×override penalty + 0.15×safety</a:t>
-            </a:r>
-            <a:endParaRPr lang="en-US" sz="900" dirty="0"/>
-          </a:p>
-        </p:txBody>
-      </p:sp>
-    </p:spTree>
-  </p:cSld>
-  <p:clrMapOvr>
-    <a:masterClrMapping/>
-  </p:clrMapOvr>
-</p:sld>
-</file>
-
-<file path=ppt/slides/slide7.xml><?xml version="1.0" encoding="utf-8"?>
-<p:sld xmlns:a="http://schemas.openxmlformats.org/drawingml/2006/main" xmlns:r="http://schemas.openxmlformats.org/officeDocument/2006/relationships" xmlns:p="http://schemas.openxmlformats.org/presentationml/2006/main">
-  <p:cSld name="Slide 7">
     <p:spTree>
       <p:nvGrpSpPr>
         <p:cNvPr id="1" name=""/>

</xml_diff>